<commit_message>
Clase 1 sin pruebas: solo Java puro con gradle run
Se quitan las pruebas JUnit y su configuración de Gradle. App muestra cada
ejemplo con más detalle porque la consola es la única evidencia. README,
guía de estudio, presentación y actividad enseñan a leer errores del
compilador en lugar de pruebas fallidas. La actividad pide una clase Tienda
que imprime 4 casos con gradle run.

Co-Authored-By: Claude Opus 5 (1M context) <noreply@anthropic.com>
Claude-Session: https://claude.ai/code/session_01L2JuF1iG72koPJkmuRWSzm
</commit_message>
<xml_diff>
--- a/material-de-apoyo/Clase1_Presentacion_Java_POO.pptx
+++ b/material-de-apoyo/Clase1_Presentacion_Java_POO.pptx
@@ -3597,7 +3597,7 @@
                 </a:solidFill>
                 <a:latin typeface="Century Gothic"/>
               </a:rPr>
-              <a:t>4 pruebas en verde con </a:t>
+              <a:t>Clase </a:t>
             </a:r>
             <a:r>
               <a:rPr b="0" sz="1800">
@@ -3606,7 +3606,25 @@
                 </a:solidFill>
                 <a:latin typeface="Consolas"/>
               </a:rPr>
-              <a:t>gradle test</a:t>
+              <a:t>Tienda</a:t>
+            </a:r>
+            <a:r>
+              <a:rPr b="0" sz="1800">
+                <a:solidFill>
+                  <a:srgbClr val="FFFFFF"/>
+                </a:solidFill>
+                <a:latin typeface="Century Gothic"/>
+              </a:rPr>
+              <a:t> que imprime 4 casos con </a:t>
+            </a:r>
+            <a:r>
+              <a:rPr b="0" sz="1800">
+                <a:solidFill>
+                  <a:srgbClr val="36B5FF"/>
+                </a:solidFill>
+                <a:latin typeface="Consolas"/>
+              </a:rPr>
+              <a:t>gradle run</a:t>
             </a:r>
             <a:r>
               <a:rPr b="0" sz="1800">
@@ -3754,7 +3772,25 @@
                 </a:solidFill>
                 <a:latin typeface="Century Gothic"/>
               </a:rPr>
-              <a:t>Captura de la ejecución en verde</a:t>
+              <a:t>Captura de </a:t>
+            </a:r>
+            <a:r>
+              <a:rPr b="0" sz="1400">
+                <a:solidFill>
+                  <a:srgbClr val="36B5FF"/>
+                </a:solidFill>
+                <a:latin typeface="Consolas"/>
+              </a:rPr>
+              <a:t>gradle run</a:t>
+            </a:r>
+            <a:r>
+              <a:rPr b="0" sz="1400">
+                <a:solidFill>
+                  <a:srgbClr val="C9D6E3"/>
+                </a:solidFill>
+                <a:latin typeface="Century Gothic"/>
+              </a:rPr>
+              <a:t> con la salida</a:t>
             </a:r>
           </a:p>
         </p:txBody>
@@ -4066,7 +4102,7 @@
                 </a:solidFill>
                 <a:latin typeface="Consolas"/>
               </a:rPr>
-              <a:t>gradle test</a:t>
+              <a:t>gradle run</a:t>
             </a:r>
             <a:r>
               <a:rPr b="0" sz="1400">
@@ -4698,7 +4734,7 @@
                 </a:solidFill>
                 <a:latin typeface="Century Gothic"/>
               </a:rPr>
-              <a:t>Pruebas con JUnit</a:t>
+              <a:t>Práctica guiada</a:t>
             </a:r>
           </a:p>
           <a:p>
@@ -4710,7 +4746,7 @@
                 </a:solidFill>
                 <a:latin typeface="Century Gothic"/>
               </a:rPr>
-              <a:t>Actividad</a:t>
+              <a:t>Modificar ejemplos y leer errores</a:t>
             </a:r>
           </a:p>
         </p:txBody>
@@ -8193,7 +8229,7 @@
                 </a:solidFill>
                 <a:latin typeface="Century Gothic"/>
               </a:rPr>
-              <a:t>Cómo lo corres en tu equipo</a:t>
+              <a:t>Cómo lo corres y cómo lees un error</a:t>
             </a:r>
           </a:p>
         </p:txBody>
@@ -8433,7 +8469,7 @@
                 </a:solidFill>
                 <a:latin typeface="Century Gothic"/>
               </a:rPr>
-              <a:t>2. gradle test</a:t>
+              <a:t>2. gradle run</a:t>
             </a:r>
           </a:p>
         </p:txBody>
@@ -8468,7 +8504,7 @@
                 </a:solidFill>
                 <a:latin typeface="Century Gothic"/>
               </a:rPr>
-              <a:t>Corre las 14 pruebas</a:t>
+              <a:t>Compila y ejecuta los ejemplos</a:t>
             </a:r>
           </a:p>
         </p:txBody>
@@ -8584,7 +8620,7 @@
                 </a:solidFill>
                 <a:latin typeface="Century Gothic"/>
               </a:rPr>
-              <a:t>3. Lee el final</a:t>
+              <a:t>3. Lee la consola</a:t>
             </a:r>
           </a:p>
         </p:txBody>
@@ -8615,6 +8651,15 @@
             <a:r>
               <a:rPr b="0" sz="1400">
                 <a:solidFill>
+                  <a:srgbClr val="C9D6E3"/>
+                </a:solidFill>
+                <a:latin typeface="Century Gothic"/>
+              </a:rPr>
+              <a:t>Un título por tema y </a:t>
+            </a:r>
+            <a:r>
+              <a:rPr b="0" sz="1400">
+                <a:solidFill>
                   <a:srgbClr val="36B5FF"/>
                 </a:solidFill>
                 <a:latin typeface="Consolas"/>
@@ -8628,16 +8673,7 @@
                 </a:solidFill>
                 <a:latin typeface="Century Gothic"/>
               </a:rPr>
-              <a:t> o </a:t>
-            </a:r>
-            <a:r>
-              <a:rPr b="0" sz="1400">
-                <a:solidFill>
-                  <a:srgbClr val="36B5FF"/>
-                </a:solidFill>
-                <a:latin typeface="Consolas"/>
-              </a:rPr>
-              <a:t>FAILED</a:t>
+              <a:t> al final</a:t>
             </a:r>
           </a:p>
         </p:txBody>
@@ -8753,7 +8789,7 @@
                 </a:solidFill>
                 <a:latin typeface="Century Gothic"/>
               </a:rPr>
-              <a:t>4. gradle run</a:t>
+              <a:t>4. Si falla</a:t>
             </a:r>
           </a:p>
         </p:txBody>
@@ -8788,7 +8824,16 @@
                 </a:solidFill>
                 <a:latin typeface="Century Gothic"/>
               </a:rPr>
-              <a:t>Muestra los ejemplos en consola</a:t>
+              <a:t>Busca archivo, línea y mensaje: </a:t>
+            </a:r>
+            <a:r>
+              <a:rPr b="0" sz="1400">
+                <a:solidFill>
+                  <a:srgbClr val="36B5FF"/>
+                </a:solidFill>
+                <a:latin typeface="Consolas"/>
+              </a:rPr>
+              <a:t>Variables.java:9: error: ';' expected</a:t>
             </a:r>
           </a:p>
         </p:txBody>
@@ -8823,7 +8868,7 @@
                 </a:solidFill>
                 <a:latin typeface="Century Gothic"/>
               </a:rPr>
-              <a:t>Si una prueba falla, busca </a:t>
+              <a:t>Otro error que vas a ver: </a:t>
             </a:r>
             <a:r>
               <a:rPr b="0" sz="1600">
@@ -8832,7 +8877,7 @@
                 </a:solidFill>
                 <a:latin typeface="Consolas"/>
               </a:rPr>
-              <a:t>expected</a:t>
+              <a:t>saldo has private access in CuentaBancaria</a:t>
             </a:r>
             <a:r>
               <a:rPr b="0" sz="1600">
@@ -8841,25 +8886,7 @@
                 </a:solidFill>
                 <a:latin typeface="Century Gothic"/>
               </a:rPr>
-              <a:t> (lo que se esperaba) y </a:t>
-            </a:r>
-            <a:r>
-              <a:rPr b="0" sz="1600">
-                <a:solidFill>
-                  <a:srgbClr val="36B5FF"/>
-                </a:solidFill>
-                <a:latin typeface="Consolas"/>
-              </a:rPr>
-              <a:t>but was</a:t>
-            </a:r>
-            <a:r>
-              <a:rPr b="0" sz="1600">
-                <a:solidFill>
-                  <a:srgbClr val="C9D6E3"/>
-                </a:solidFill>
-                <a:latin typeface="Century Gothic"/>
-              </a:rPr>
-              <a:t> (lo que llegó).</a:t>
+              <a:t>. Es el encapsulamiento protegiendo el dato.</a:t>
             </a:r>
           </a:p>
         </p:txBody>

</xml_diff>

<commit_message>
Clase 1: interfaces con implements y la diferencia con extends
Paquete nuevo interfaces con Volador, Pajaro y Avion. App queda con 8
secciones: la 7 muestra extends frente a implements y la sobrecarga pasa
a la 8. README, guía de estudio y presentación explican la diferencia con
la tabla comparativa y la salida real; la guía de prerrequisitos ajusta la
numeración de la última sección.

Co-Authored-By: Claude Opus 5 (1M context) <noreply@anthropic.com>
Claude-Session: https://claude.ai/code/session_01L2JuF1iG72koPJkmuRWSzm
</commit_message>
<xml_diff>
--- a/material-de-apoyo/Clase1_Presentacion_Java_POO.pptx
+++ b/material-de-apoyo/Clase1_Presentacion_Java_POO.pptx
@@ -13,6 +13,7 @@
     <p:sldId id="261" r:id="rId7"/>
     <p:sldId id="262" r:id="rId8"/>
     <p:sldId id="263" r:id="rId9"/>
+    <p:sldId id="267" r:id="rId17"/>
     <p:sldId id="266" r:id="rId16"/>
     <p:sldId id="264" r:id="rId10"/>
     <p:sldId id="265" r:id="rId11"/>
@@ -3365,7 +3366,7 @@
         <p:spPr>
           <a:xfrm>
             <a:off x="548640" y="411480"/>
-            <a:ext cx="1124712" cy="329184"/>
+            <a:ext cx="1362456" cy="329184"/>
           </a:xfrm>
           <a:prstGeom prst="roundRect">
             <a:avLst>
@@ -3405,7 +3406,7 @@
                 </a:solidFill>
                 <a:latin typeface="Century Gothic"/>
               </a:rPr>
-              <a:t>CIERRE</a:t>
+              <a:t>PRÁCTICA</a:t>
             </a:r>
           </a:p>
         </p:txBody>
@@ -3440,225 +3441,21 @@
                 </a:solidFill>
                 <a:latin typeface="Century Gothic"/>
               </a:rPr>
-              <a:t>Tu actividad</a:t>
-            </a:r>
-          </a:p>
-        </p:txBody>
-      </p:sp>
-      <p:sp>
-        <p:nvSpPr>
-          <p:cNvPr id="4" name="TextBox 3"/>
-          <p:cNvSpPr txBox="1"/>
-          <p:nvPr/>
-        </p:nvSpPr>
-        <p:spPr>
-          <a:xfrm>
-            <a:off x="548640" y="1737360"/>
-            <a:ext cx="6766560" cy="4114800"/>
-          </a:xfrm>
-          <a:prstGeom prst="rect">
-            <a:avLst/>
-          </a:prstGeom>
-          <a:noFill/>
-        </p:spPr>
-        <p:txBody>
-          <a:bodyPr wrap="square">
-            <a:spAutoFit/>
-          </a:bodyPr>
-          <a:lstStyle/>
-          <a:p>
-            <a:pPr>
-              <a:spcAft>
-                <a:spcPts val="1200"/>
-              </a:spcAft>
-            </a:pPr>
-            <a:r>
-              <a:rPr sz="1800" b="1">
-                <a:solidFill>
-                  <a:srgbClr val="36B5FF"/>
-                </a:solidFill>
-                <a:latin typeface="Century Gothic"/>
-              </a:rPr>
-              <a:t>✓  </a:t>
-            </a:r>
-            <a:r>
-              <a:rPr sz="1800" b="0">
-                <a:solidFill>
-                  <a:srgbClr val="FFFFFF"/>
-                </a:solidFill>
-                <a:latin typeface="Century Gothic"/>
-              </a:rPr>
-              <a:t>Clase </a:t>
-            </a:r>
-            <a:r>
-              <a:rPr sz="1800" b="0">
-                <a:solidFill>
-                  <a:srgbClr val="36B5FF"/>
-                </a:solidFill>
-                <a:latin typeface="Consolas"/>
-              </a:rPr>
-              <a:t>Producto</a:t>
-            </a:r>
-            <a:r>
-              <a:rPr sz="1800" b="0">
-                <a:solidFill>
-                  <a:srgbClr val="FFFFFF"/>
-                </a:solidFill>
-                <a:latin typeface="Century Gothic"/>
-              </a:rPr>
-              <a:t> con precio privado que no acepta negativos.</a:t>
-            </a:r>
-          </a:p>
-          <a:p>
-            <a:pPr>
-              <a:spcAft>
-                <a:spcPts val="1200"/>
-              </a:spcAft>
-            </a:pPr>
-            <a:r>
-              <a:rPr sz="1800" b="1">
-                <a:solidFill>
-                  <a:srgbClr val="36B5FF"/>
-                </a:solidFill>
-                <a:latin typeface="Century Gothic"/>
-              </a:rPr>
-              <a:t>✓  </a:t>
-            </a:r>
-            <a:r>
-              <a:rPr sz="1800" b="0">
-                <a:solidFill>
-                  <a:srgbClr val="FFFFFF"/>
-                </a:solidFill>
-                <a:latin typeface="Century Gothic"/>
-              </a:rPr>
-              <a:t>Descuento con </a:t>
-            </a:r>
-            <a:r>
-              <a:rPr sz="1800" b="0">
-                <a:solidFill>
-                  <a:srgbClr val="36B5FF"/>
-                </a:solidFill>
-                <a:latin typeface="Consolas"/>
-              </a:rPr>
-              <a:t>if</a:t>
-            </a:r>
-            <a:r>
-              <a:rPr sz="1800" b="0">
-                <a:solidFill>
-                  <a:srgbClr val="FFFFFF"/>
-                </a:solidFill>
-                <a:latin typeface="Century Gothic"/>
-              </a:rPr>
-              <a:t>.</a:t>
-            </a:r>
-          </a:p>
-          <a:p>
-            <a:pPr>
-              <a:spcAft>
-                <a:spcPts val="1200"/>
-              </a:spcAft>
-            </a:pPr>
-            <a:r>
-              <a:rPr sz="1800" b="1">
-                <a:solidFill>
-                  <a:srgbClr val="36B5FF"/>
-                </a:solidFill>
-                <a:latin typeface="Century Gothic"/>
-              </a:rPr>
-              <a:t>✓  </a:t>
-            </a:r>
-            <a:r>
-              <a:rPr sz="1800" b="0">
-                <a:solidFill>
-                  <a:srgbClr val="36B5FF"/>
-                </a:solidFill>
-                <a:latin typeface="Consolas"/>
-              </a:rPr>
-              <a:t>ProductoEnOferta</a:t>
-            </a:r>
-            <a:r>
-              <a:rPr sz="1800" b="0">
-                <a:solidFill>
-                  <a:srgbClr val="FFFFFF"/>
-                </a:solidFill>
-                <a:latin typeface="Century Gothic"/>
-              </a:rPr>
-              <a:t> que hereda y sobrescribe.</a:t>
-            </a:r>
-          </a:p>
-          <a:p>
-            <a:pPr>
-              <a:spcAft>
-                <a:spcPts val="1200"/>
-              </a:spcAft>
-            </a:pPr>
-            <a:r>
-              <a:rPr sz="1800" b="1">
-                <a:solidFill>
-                  <a:srgbClr val="36B5FF"/>
-                </a:solidFill>
-                <a:latin typeface="Century Gothic"/>
-              </a:rPr>
-              <a:t>✓  </a:t>
-            </a:r>
-            <a:r>
-              <a:rPr sz="1800" b="0">
-                <a:solidFill>
-                  <a:srgbClr val="FFFFFF"/>
-                </a:solidFill>
-                <a:latin typeface="Century Gothic"/>
-              </a:rPr>
-              <a:t>Clase </a:t>
-            </a:r>
-            <a:r>
-              <a:rPr sz="1800" b="0">
-                <a:solidFill>
-                  <a:srgbClr val="36B5FF"/>
-                </a:solidFill>
-                <a:latin typeface="Consolas"/>
-              </a:rPr>
-              <a:t>Tienda</a:t>
-            </a:r>
-            <a:r>
-              <a:rPr sz="1800" b="0">
-                <a:solidFill>
-                  <a:srgbClr val="FFFFFF"/>
-                </a:solidFill>
-                <a:latin typeface="Century Gothic"/>
-              </a:rPr>
-              <a:t> que imprime 4 casos con </a:t>
-            </a:r>
-            <a:r>
-              <a:rPr sz="1800" b="0">
-                <a:solidFill>
-                  <a:srgbClr val="36B5FF"/>
-                </a:solidFill>
-                <a:latin typeface="Consolas"/>
-              </a:rPr>
-              <a:t>gradle run</a:t>
-            </a:r>
-            <a:r>
-              <a:rPr sz="1800" b="0">
-                <a:solidFill>
-                  <a:srgbClr val="FFFFFF"/>
-                </a:solidFill>
-                <a:latin typeface="Century Gothic"/>
-              </a:rPr>
-              <a:t>.</a:t>
-            </a:r>
-          </a:p>
-        </p:txBody>
-      </p:sp>
-      <p:sp>
-        <p:nvSpPr>
-          <p:cNvPr id="5" name="Rounded Rectangle 4"/>
+              <a:t>Cómo lo corres y cómo lees un error</a:t>
+            </a:r>
+          </a:p>
+        </p:txBody>
+      </p:sp>
+      <p:sp>
+        <p:nvSpPr>
+          <p:cNvPr id="4" name="Rounded Rectangle 3"/>
           <p:cNvSpPr/>
           <p:nvPr/>
         </p:nvSpPr>
         <p:spPr>
           <a:xfrm>
-            <a:off x="7680960" y="1737360"/>
-            <a:ext cx="3962095" cy="3931920"/>
+            <a:off x="548640" y="2057400"/>
+            <a:ext cx="2464993" cy="2651760"/>
           </a:xfrm>
           <a:prstGeom prst="roundRect">
             <a:avLst>
@@ -3698,14 +3495,14 @@
       </p:sp>
       <p:sp>
         <p:nvSpPr>
-          <p:cNvPr id="6" name="TextBox 5"/>
+          <p:cNvPr id="5" name="TextBox 4"/>
           <p:cNvSpPr txBox="1"/>
           <p:nvPr/>
         </p:nvSpPr>
         <p:spPr>
           <a:xfrm>
-            <a:off x="7909560" y="1965960"/>
-            <a:ext cx="3504895" cy="548640"/>
+            <a:off x="777240" y="2286000"/>
+            <a:ext cx="2007793" cy="548640"/>
           </a:xfrm>
           <a:prstGeom prst="rect">
             <a:avLst/>
@@ -3726,21 +3523,21 @@
                 </a:solidFill>
                 <a:latin typeface="Century Gothic"/>
               </a:rPr>
-              <a:t>Entrega</a:t>
-            </a:r>
-          </a:p>
-        </p:txBody>
-      </p:sp>
-      <p:sp>
-        <p:nvSpPr>
-          <p:cNvPr id="7" name="TextBox 6"/>
+              <a:t>1. PowerShell</a:t>
+            </a:r>
+          </a:p>
+        </p:txBody>
+      </p:sp>
+      <p:sp>
+        <p:nvSpPr>
+          <p:cNvPr id="6" name="TextBox 5"/>
           <p:cNvSpPr txBox="1"/>
           <p:nvPr/>
         </p:nvSpPr>
         <p:spPr>
           <a:xfrm>
-            <a:off x="7909560" y="2468880"/>
-            <a:ext cx="3504895" cy="3017520"/>
+            <a:off x="777240" y="2788920"/>
+            <a:ext cx="2007793" cy="1737360"/>
           </a:xfrm>
           <a:prstGeom prst="rect">
             <a:avLst/>
@@ -3757,67 +3554,117 @@
             <a:r>
               <a:rPr sz="1400" b="0">
                 <a:solidFill>
+                  <a:srgbClr val="36B5FF"/>
+                </a:solidFill>
+                <a:latin typeface="Consolas"/>
+              </a:rPr>
+              <a:t>cd</a:t>
+            </a:r>
+            <a:r>
+              <a:rPr sz="1400" b="0">
+                <a:solidFill>
                   <a:srgbClr val="C9D6E3"/>
                 </a:solidFill>
                 <a:latin typeface="Century Gothic"/>
               </a:rPr>
-              <a:t>Miércoles 23 de septiembre de 2026, 8:00 a.m.</a:t>
-            </a:r>
-          </a:p>
-          <a:p>
-            <a:pPr algn="l"/>
-            <a:r>
-              <a:rPr sz="1400" b="0">
-                <a:solidFill>
-                  <a:srgbClr val="C9D6E3"/>
-                </a:solidFill>
-                <a:latin typeface="Century Gothic"/>
-              </a:rPr>
-              <a:t>Repositorio en GitHub o .zip sin la carpeta build</a:t>
-            </a:r>
-          </a:p>
-          <a:p>
-            <a:pPr algn="l"/>
-            <a:r>
-              <a:rPr sz="1400" b="0">
-                <a:solidFill>
-                  <a:srgbClr val="C9D6E3"/>
-                </a:solidFill>
-                <a:latin typeface="Century Gothic"/>
-              </a:rPr>
-              <a:t>Captura de </a:t>
-            </a:r>
-            <a:r>
-              <a:rPr sz="1400" b="0">
-                <a:solidFill>
-                  <a:srgbClr val="36B5FF"/>
-                </a:solidFill>
-                <a:latin typeface="Consolas"/>
-              </a:rPr>
-              <a:t>gradle run</a:t>
-            </a:r>
-            <a:r>
-              <a:rPr sz="1400" b="0">
-                <a:solidFill>
-                  <a:srgbClr val="C9D6E3"/>
-                </a:solidFill>
-                <a:latin typeface="Century Gothic"/>
-              </a:rPr>
-              <a:t> con la salida</a:t>
-            </a:r>
-          </a:p>
-        </p:txBody>
-      </p:sp>
-      <p:sp>
-        <p:nvSpPr>
-          <p:cNvPr id="8" name="TextBox 7"/>
+              <a:t> a la carpeta del proyecto</a:t>
+            </a:r>
+          </a:p>
+        </p:txBody>
+      </p:sp>
+      <p:cxnSp>
+        <p:nvCxnSpPr>
+          <p:cNvPr id="7" name="Connector 6"/>
+          <p:cNvCxnSpPr/>
+          <p:nvPr/>
+        </p:nvCxnSpPr>
+        <p:spPr>
+          <a:xfrm>
+            <a:off x="3059353" y="3383280"/>
+            <a:ext cx="320040" cy="0"/>
+          </a:xfrm>
+          <a:prstGeom prst="line">
+            <a:avLst/>
+          </a:prstGeom>
+          <a:ln w="31750">
+            <a:solidFill>
+              <a:srgbClr val="36B5FF"/>
+            </a:solidFill>
+            <a:tailEnd type="triangle"/>
+          </a:ln>
+        </p:spPr>
+        <p:style>
+          <a:lnRef idx="2">
+            <a:schemeClr val="accent1"/>
+          </a:lnRef>
+          <a:fillRef idx="0">
+            <a:schemeClr val="accent1"/>
+          </a:fillRef>
+          <a:effectRef idx="1">
+            <a:schemeClr val="accent1"/>
+          </a:effectRef>
+          <a:fontRef idx="minor">
+            <a:schemeClr val="tx1"/>
+          </a:fontRef>
+        </p:style>
+      </p:cxnSp>
+      <p:sp>
+        <p:nvSpPr>
+          <p:cNvPr id="8" name="Rounded Rectangle 7"/>
+          <p:cNvSpPr/>
+          <p:nvPr/>
+        </p:nvSpPr>
+        <p:spPr>
+          <a:xfrm>
+            <a:off x="3425113" y="2057400"/>
+            <a:ext cx="2464993" cy="2651760"/>
+          </a:xfrm>
+          <a:prstGeom prst="roundRect">
+            <a:avLst>
+              <a:gd name="adj" fmla="val 6000"/>
+            </a:avLst>
+          </a:prstGeom>
+          <a:solidFill>
+            <a:srgbClr val="08264F"/>
+          </a:solidFill>
+          <a:ln w="15875">
+            <a:solidFill>
+              <a:srgbClr val="5EA7D8"/>
+            </a:solidFill>
+          </a:ln>
+        </p:spPr>
+        <p:style>
+          <a:lnRef idx="1">
+            <a:schemeClr val="accent1"/>
+          </a:lnRef>
+          <a:fillRef idx="3">
+            <a:schemeClr val="accent1"/>
+          </a:fillRef>
+          <a:effectRef idx="2">
+            <a:schemeClr val="accent1"/>
+          </a:effectRef>
+          <a:fontRef idx="minor">
+            <a:schemeClr val="lt1"/>
+          </a:fontRef>
+        </p:style>
+        <p:txBody>
+          <a:bodyPr rtlCol="0" anchor="ctr"/>
+          <a:lstStyle/>
+          <a:p>
+            <a:endParaRPr/>
+          </a:p>
+        </p:txBody>
+      </p:sp>
+      <p:sp>
+        <p:nvSpPr>
+          <p:cNvPr id="9" name="TextBox 8"/>
           <p:cNvSpPr txBox="1"/>
           <p:nvPr/>
         </p:nvSpPr>
         <p:spPr>
           <a:xfrm>
-            <a:off x="548640" y="6400800"/>
-            <a:ext cx="8229600" cy="274320"/>
+            <a:off x="3653713" y="2286000"/>
+            <a:ext cx="2007793" cy="548640"/>
           </a:xfrm>
           <a:prstGeom prst="rect">
             <a:avLst/>
@@ -3832,6 +3679,462 @@
           <a:p>
             <a:pPr algn="l"/>
             <a:r>
+              <a:rPr sz="1800" b="1">
+                <a:solidFill>
+                  <a:srgbClr val="FFFFFF"/>
+                </a:solidFill>
+                <a:latin typeface="Century Gothic"/>
+              </a:rPr>
+              <a:t>2. gradle run</a:t>
+            </a:r>
+          </a:p>
+        </p:txBody>
+      </p:sp>
+      <p:sp>
+        <p:nvSpPr>
+          <p:cNvPr id="10" name="TextBox 9"/>
+          <p:cNvSpPr txBox="1"/>
+          <p:nvPr/>
+        </p:nvSpPr>
+        <p:spPr>
+          <a:xfrm>
+            <a:off x="3653713" y="2788920"/>
+            <a:ext cx="2007793" cy="1737360"/>
+          </a:xfrm>
+          <a:prstGeom prst="rect">
+            <a:avLst/>
+          </a:prstGeom>
+          <a:noFill/>
+        </p:spPr>
+        <p:txBody>
+          <a:bodyPr wrap="square" lIns="0" rIns="0" anchor="t">
+            <a:spAutoFit/>
+          </a:bodyPr>
+          <a:lstStyle/>
+          <a:p>
+            <a:pPr algn="l"/>
+            <a:r>
+              <a:rPr sz="1400" b="0">
+                <a:solidFill>
+                  <a:srgbClr val="C9D6E3"/>
+                </a:solidFill>
+                <a:latin typeface="Century Gothic"/>
+              </a:rPr>
+              <a:t>Compila y ejecuta los ejemplos</a:t>
+            </a:r>
+          </a:p>
+        </p:txBody>
+      </p:sp>
+      <p:cxnSp>
+        <p:nvCxnSpPr>
+          <p:cNvPr id="11" name="Connector 10"/>
+          <p:cNvCxnSpPr/>
+          <p:nvPr/>
+        </p:nvCxnSpPr>
+        <p:spPr>
+          <a:xfrm>
+            <a:off x="5935826" y="3383280"/>
+            <a:ext cx="320040" cy="0"/>
+          </a:xfrm>
+          <a:prstGeom prst="line">
+            <a:avLst/>
+          </a:prstGeom>
+          <a:ln w="31750">
+            <a:solidFill>
+              <a:srgbClr val="36B5FF"/>
+            </a:solidFill>
+            <a:tailEnd type="triangle"/>
+          </a:ln>
+        </p:spPr>
+        <p:style>
+          <a:lnRef idx="2">
+            <a:schemeClr val="accent1"/>
+          </a:lnRef>
+          <a:fillRef idx="0">
+            <a:schemeClr val="accent1"/>
+          </a:fillRef>
+          <a:effectRef idx="1">
+            <a:schemeClr val="accent1"/>
+          </a:effectRef>
+          <a:fontRef idx="minor">
+            <a:schemeClr val="tx1"/>
+          </a:fontRef>
+        </p:style>
+      </p:cxnSp>
+      <p:sp>
+        <p:nvSpPr>
+          <p:cNvPr id="12" name="Rounded Rectangle 11"/>
+          <p:cNvSpPr/>
+          <p:nvPr/>
+        </p:nvSpPr>
+        <p:spPr>
+          <a:xfrm>
+            <a:off x="6301586" y="2057400"/>
+            <a:ext cx="2464993" cy="2651760"/>
+          </a:xfrm>
+          <a:prstGeom prst="roundRect">
+            <a:avLst>
+              <a:gd name="adj" fmla="val 6000"/>
+            </a:avLst>
+          </a:prstGeom>
+          <a:solidFill>
+            <a:srgbClr val="0B2C59"/>
+          </a:solidFill>
+          <a:ln w="15875">
+            <a:solidFill>
+              <a:srgbClr val="5EA7D8"/>
+            </a:solidFill>
+          </a:ln>
+        </p:spPr>
+        <p:style>
+          <a:lnRef idx="1">
+            <a:schemeClr val="accent1"/>
+          </a:lnRef>
+          <a:fillRef idx="3">
+            <a:schemeClr val="accent1"/>
+          </a:fillRef>
+          <a:effectRef idx="2">
+            <a:schemeClr val="accent1"/>
+          </a:effectRef>
+          <a:fontRef idx="minor">
+            <a:schemeClr val="lt1"/>
+          </a:fontRef>
+        </p:style>
+        <p:txBody>
+          <a:bodyPr rtlCol="0" anchor="ctr"/>
+          <a:lstStyle/>
+          <a:p>
+            <a:endParaRPr/>
+          </a:p>
+        </p:txBody>
+      </p:sp>
+      <p:sp>
+        <p:nvSpPr>
+          <p:cNvPr id="13" name="TextBox 12"/>
+          <p:cNvSpPr txBox="1"/>
+          <p:nvPr/>
+        </p:nvSpPr>
+        <p:spPr>
+          <a:xfrm>
+            <a:off x="6530186" y="2286000"/>
+            <a:ext cx="2007793" cy="548640"/>
+          </a:xfrm>
+          <a:prstGeom prst="rect">
+            <a:avLst/>
+          </a:prstGeom>
+          <a:noFill/>
+        </p:spPr>
+        <p:txBody>
+          <a:bodyPr wrap="square" lIns="0" rIns="0" anchor="t">
+            <a:spAutoFit/>
+          </a:bodyPr>
+          <a:lstStyle/>
+          <a:p>
+            <a:pPr algn="l"/>
+            <a:r>
+              <a:rPr sz="1800" b="1">
+                <a:solidFill>
+                  <a:srgbClr val="FFFFFF"/>
+                </a:solidFill>
+                <a:latin typeface="Century Gothic"/>
+              </a:rPr>
+              <a:t>3. Lee la consola</a:t>
+            </a:r>
+          </a:p>
+        </p:txBody>
+      </p:sp>
+      <p:sp>
+        <p:nvSpPr>
+          <p:cNvPr id="14" name="TextBox 13"/>
+          <p:cNvSpPr txBox="1"/>
+          <p:nvPr/>
+        </p:nvSpPr>
+        <p:spPr>
+          <a:xfrm>
+            <a:off x="6530186" y="2788920"/>
+            <a:ext cx="2007793" cy="1737360"/>
+          </a:xfrm>
+          <a:prstGeom prst="rect">
+            <a:avLst/>
+          </a:prstGeom>
+          <a:noFill/>
+        </p:spPr>
+        <p:txBody>
+          <a:bodyPr wrap="square" lIns="0" rIns="0" anchor="t">
+            <a:spAutoFit/>
+          </a:bodyPr>
+          <a:lstStyle/>
+          <a:p>
+            <a:pPr algn="l"/>
+            <a:r>
+              <a:rPr sz="1400" b="0">
+                <a:solidFill>
+                  <a:srgbClr val="C9D6E3"/>
+                </a:solidFill>
+                <a:latin typeface="Century Gothic"/>
+              </a:rPr>
+              <a:t>Un título por tema y </a:t>
+            </a:r>
+            <a:r>
+              <a:rPr sz="1400" b="0">
+                <a:solidFill>
+                  <a:srgbClr val="36B5FF"/>
+                </a:solidFill>
+                <a:latin typeface="Consolas"/>
+              </a:rPr>
+              <a:t>BUILD SUCCESSFUL</a:t>
+            </a:r>
+            <a:r>
+              <a:rPr sz="1400" b="0">
+                <a:solidFill>
+                  <a:srgbClr val="C9D6E3"/>
+                </a:solidFill>
+                <a:latin typeface="Century Gothic"/>
+              </a:rPr>
+              <a:t> al final</a:t>
+            </a:r>
+          </a:p>
+        </p:txBody>
+      </p:sp>
+      <p:cxnSp>
+        <p:nvCxnSpPr>
+          <p:cNvPr id="15" name="Connector 14"/>
+          <p:cNvCxnSpPr/>
+          <p:nvPr/>
+        </p:nvCxnSpPr>
+        <p:spPr>
+          <a:xfrm>
+            <a:off x="8812299" y="3383280"/>
+            <a:ext cx="320040" cy="0"/>
+          </a:xfrm>
+          <a:prstGeom prst="line">
+            <a:avLst/>
+          </a:prstGeom>
+          <a:ln w="31750">
+            <a:solidFill>
+              <a:srgbClr val="36B5FF"/>
+            </a:solidFill>
+            <a:tailEnd type="triangle"/>
+          </a:ln>
+        </p:spPr>
+        <p:style>
+          <a:lnRef idx="2">
+            <a:schemeClr val="accent1"/>
+          </a:lnRef>
+          <a:fillRef idx="0">
+            <a:schemeClr val="accent1"/>
+          </a:fillRef>
+          <a:effectRef idx="1">
+            <a:schemeClr val="accent1"/>
+          </a:effectRef>
+          <a:fontRef idx="minor">
+            <a:schemeClr val="tx1"/>
+          </a:fontRef>
+        </p:style>
+      </p:cxnSp>
+      <p:sp>
+        <p:nvSpPr>
+          <p:cNvPr id="16" name="Rounded Rectangle 15"/>
+          <p:cNvSpPr/>
+          <p:nvPr/>
+        </p:nvSpPr>
+        <p:spPr>
+          <a:xfrm>
+            <a:off x="9178059" y="2057400"/>
+            <a:ext cx="2464993" cy="2651760"/>
+          </a:xfrm>
+          <a:prstGeom prst="roundRect">
+            <a:avLst>
+              <a:gd name="adj" fmla="val 6000"/>
+            </a:avLst>
+          </a:prstGeom>
+          <a:solidFill>
+            <a:srgbClr val="08264F"/>
+          </a:solidFill>
+          <a:ln w="15875">
+            <a:solidFill>
+              <a:srgbClr val="5EA7D8"/>
+            </a:solidFill>
+          </a:ln>
+        </p:spPr>
+        <p:style>
+          <a:lnRef idx="1">
+            <a:schemeClr val="accent1"/>
+          </a:lnRef>
+          <a:fillRef idx="3">
+            <a:schemeClr val="accent1"/>
+          </a:fillRef>
+          <a:effectRef idx="2">
+            <a:schemeClr val="accent1"/>
+          </a:effectRef>
+          <a:fontRef idx="minor">
+            <a:schemeClr val="lt1"/>
+          </a:fontRef>
+        </p:style>
+        <p:txBody>
+          <a:bodyPr rtlCol="0" anchor="ctr"/>
+          <a:lstStyle/>
+          <a:p>
+            <a:endParaRPr/>
+          </a:p>
+        </p:txBody>
+      </p:sp>
+      <p:sp>
+        <p:nvSpPr>
+          <p:cNvPr id="17" name="TextBox 16"/>
+          <p:cNvSpPr txBox="1"/>
+          <p:nvPr/>
+        </p:nvSpPr>
+        <p:spPr>
+          <a:xfrm>
+            <a:off x="9406659" y="2286000"/>
+            <a:ext cx="2007793" cy="548640"/>
+          </a:xfrm>
+          <a:prstGeom prst="rect">
+            <a:avLst/>
+          </a:prstGeom>
+          <a:noFill/>
+        </p:spPr>
+        <p:txBody>
+          <a:bodyPr wrap="square" lIns="0" rIns="0" anchor="t">
+            <a:spAutoFit/>
+          </a:bodyPr>
+          <a:lstStyle/>
+          <a:p>
+            <a:pPr algn="l"/>
+            <a:r>
+              <a:rPr sz="1800" b="1">
+                <a:solidFill>
+                  <a:srgbClr val="FFFFFF"/>
+                </a:solidFill>
+                <a:latin typeface="Century Gothic"/>
+              </a:rPr>
+              <a:t>4. Si falla</a:t>
+            </a:r>
+          </a:p>
+        </p:txBody>
+      </p:sp>
+      <p:sp>
+        <p:nvSpPr>
+          <p:cNvPr id="18" name="TextBox 17"/>
+          <p:cNvSpPr txBox="1"/>
+          <p:nvPr/>
+        </p:nvSpPr>
+        <p:spPr>
+          <a:xfrm>
+            <a:off x="9406659" y="2788920"/>
+            <a:ext cx="2007793" cy="1737360"/>
+          </a:xfrm>
+          <a:prstGeom prst="rect">
+            <a:avLst/>
+          </a:prstGeom>
+          <a:noFill/>
+        </p:spPr>
+        <p:txBody>
+          <a:bodyPr wrap="square" lIns="0" rIns="0" anchor="t">
+            <a:spAutoFit/>
+          </a:bodyPr>
+          <a:lstStyle/>
+          <a:p>
+            <a:pPr algn="l"/>
+            <a:r>
+              <a:rPr sz="1400" b="0">
+                <a:solidFill>
+                  <a:srgbClr val="C9D6E3"/>
+                </a:solidFill>
+                <a:latin typeface="Century Gothic"/>
+              </a:rPr>
+              <a:t>Busca archivo, línea y mensaje: </a:t>
+            </a:r>
+            <a:r>
+              <a:rPr sz="1400" b="0">
+                <a:solidFill>
+                  <a:srgbClr val="36B5FF"/>
+                </a:solidFill>
+                <a:latin typeface="Consolas"/>
+              </a:rPr>
+              <a:t>Variables.java:9: error: ';' expected</a:t>
+            </a:r>
+          </a:p>
+        </p:txBody>
+      </p:sp>
+      <p:sp>
+        <p:nvSpPr>
+          <p:cNvPr id="19" name="TextBox 18"/>
+          <p:cNvSpPr txBox="1"/>
+          <p:nvPr/>
+        </p:nvSpPr>
+        <p:spPr>
+          <a:xfrm>
+            <a:off x="548640" y="5029200"/>
+            <a:ext cx="11094415" cy="1097280"/>
+          </a:xfrm>
+          <a:prstGeom prst="rect">
+            <a:avLst/>
+          </a:prstGeom>
+          <a:noFill/>
+        </p:spPr>
+        <p:txBody>
+          <a:bodyPr wrap="square" lIns="0" rIns="0" anchor="t">
+            <a:spAutoFit/>
+          </a:bodyPr>
+          <a:lstStyle/>
+          <a:p>
+            <a:pPr algn="l"/>
+            <a:r>
+              <a:rPr sz="1600" b="0">
+                <a:solidFill>
+                  <a:srgbClr val="C9D6E3"/>
+                </a:solidFill>
+                <a:latin typeface="Century Gothic"/>
+              </a:rPr>
+              <a:t>Otro error que vas a ver: </a:t>
+            </a:r>
+            <a:r>
+              <a:rPr sz="1600" b="0">
+                <a:solidFill>
+                  <a:srgbClr val="36B5FF"/>
+                </a:solidFill>
+                <a:latin typeface="Consolas"/>
+              </a:rPr>
+              <a:t>saldo has private access in CuentaBancaria</a:t>
+            </a:r>
+            <a:r>
+              <a:rPr sz="1600" b="0">
+                <a:solidFill>
+                  <a:srgbClr val="C9D6E3"/>
+                </a:solidFill>
+                <a:latin typeface="Century Gothic"/>
+              </a:rPr>
+              <a:t>. Es el encapsulamiento protegiendo el dato.</a:t>
+            </a:r>
+          </a:p>
+        </p:txBody>
+      </p:sp>
+      <p:sp>
+        <p:nvSpPr>
+          <p:cNvPr id="20" name="TextBox 19"/>
+          <p:cNvSpPr txBox="1"/>
+          <p:nvPr/>
+        </p:nvSpPr>
+        <p:spPr>
+          <a:xfrm>
+            <a:off x="548640" y="6400800"/>
+            <a:ext cx="8229600" cy="274320"/>
+          </a:xfrm>
+          <a:prstGeom prst="rect">
+            <a:avLst/>
+          </a:prstGeom>
+          <a:noFill/>
+        </p:spPr>
+        <p:txBody>
+          <a:bodyPr wrap="square" lIns="0" rIns="0" anchor="t">
+            <a:spAutoFit/>
+          </a:bodyPr>
+          <a:lstStyle/>
+          <a:p>
+            <a:pPr algn="l"/>
+            <a:r>
               <a:rPr sz="1200" b="0">
                 <a:solidFill>
                   <a:srgbClr val="C9D6E3"/>
@@ -3845,7 +4148,7 @@
       </p:sp>
       <p:sp>
         <p:nvSpPr>
-          <p:cNvPr id="9" name="TextBox 8"/>
+          <p:cNvPr id="21" name="TextBox 20"/>
           <p:cNvSpPr txBox="1"/>
           <p:nvPr/>
         </p:nvSpPr>
@@ -3887,6 +4190,561 @@
 </file>
 
 <file path=ppt/slides/slide11.xml><?xml version="1.0" encoding="utf-8"?>
+<p:sld xmlns:a="http://schemas.openxmlformats.org/drawingml/2006/main" xmlns:r="http://schemas.openxmlformats.org/officeDocument/2006/relationships" xmlns:p="http://schemas.openxmlformats.org/presentationml/2006/main">
+  <p:cSld>
+    <p:bg>
+      <p:bgPr>
+        <a:solidFill>
+          <a:srgbClr val="06142C"/>
+        </a:solidFill>
+        <a:effectLst/>
+      </p:bgPr>
+    </p:bg>
+    <p:spTree>
+      <p:nvGrpSpPr>
+        <p:cNvPr id="1" name=""/>
+        <p:cNvGrpSpPr/>
+        <p:nvPr/>
+      </p:nvGrpSpPr>
+      <p:grpSpPr>
+        <a:xfrm>
+          <a:off x="0" y="0"/>
+          <a:ext cx="0" cy="0"/>
+          <a:chOff x="0" y="0"/>
+          <a:chExt cx="0" cy="0"/>
+        </a:xfrm>
+      </p:grpSpPr>
+      <p:sp>
+        <p:nvSpPr>
+          <p:cNvPr id="2" name="Rounded Rectangle 1"/>
+          <p:cNvSpPr/>
+          <p:nvPr/>
+        </p:nvSpPr>
+        <p:spPr>
+          <a:xfrm>
+            <a:off x="548640" y="411480"/>
+            <a:ext cx="1124712" cy="329184"/>
+          </a:xfrm>
+          <a:prstGeom prst="roundRect">
+            <a:avLst>
+              <a:gd name="adj" fmla="val 50000"/>
+            </a:avLst>
+          </a:prstGeom>
+          <a:solidFill>
+            <a:srgbClr val="0072BC"/>
+          </a:solidFill>
+          <a:ln>
+            <a:noFill/>
+          </a:ln>
+        </p:spPr>
+        <p:style>
+          <a:lnRef idx="1">
+            <a:schemeClr val="accent1"/>
+          </a:lnRef>
+          <a:fillRef idx="3">
+            <a:schemeClr val="accent1"/>
+          </a:fillRef>
+          <a:effectRef idx="2">
+            <a:schemeClr val="accent1"/>
+          </a:effectRef>
+          <a:fontRef idx="minor">
+            <a:schemeClr val="lt1"/>
+          </a:fontRef>
+        </p:style>
+        <p:txBody>
+          <a:bodyPr wrap="none" tIns="0" bIns="0" rtlCol="0" anchor="ctr"/>
+          <a:lstStyle/>
+          <a:p>
+            <a:pPr algn="ctr"/>
+            <a:r>
+              <a:rPr sz="1200" b="1">
+                <a:solidFill>
+                  <a:srgbClr val="FFFFFF"/>
+                </a:solidFill>
+                <a:latin typeface="Century Gothic"/>
+              </a:rPr>
+              <a:t>CIERRE</a:t>
+            </a:r>
+          </a:p>
+        </p:txBody>
+      </p:sp>
+      <p:sp>
+        <p:nvSpPr>
+          <p:cNvPr id="3" name="TextBox 2"/>
+          <p:cNvSpPr txBox="1"/>
+          <p:nvPr/>
+        </p:nvSpPr>
+        <p:spPr>
+          <a:xfrm>
+            <a:off x="548640" y="868680"/>
+            <a:ext cx="11094415" cy="731520"/>
+          </a:xfrm>
+          <a:prstGeom prst="rect">
+            <a:avLst/>
+          </a:prstGeom>
+          <a:noFill/>
+        </p:spPr>
+        <p:txBody>
+          <a:bodyPr wrap="square" lIns="0" rIns="0" anchor="t">
+            <a:spAutoFit/>
+          </a:bodyPr>
+          <a:lstStyle/>
+          <a:p>
+            <a:pPr algn="l"/>
+            <a:r>
+              <a:rPr sz="2800" b="1">
+                <a:solidFill>
+                  <a:srgbClr val="FFFFFF"/>
+                </a:solidFill>
+                <a:latin typeface="Century Gothic"/>
+              </a:rPr>
+              <a:t>Tu actividad</a:t>
+            </a:r>
+          </a:p>
+        </p:txBody>
+      </p:sp>
+      <p:sp>
+        <p:nvSpPr>
+          <p:cNvPr id="4" name="TextBox 3"/>
+          <p:cNvSpPr txBox="1"/>
+          <p:nvPr/>
+        </p:nvSpPr>
+        <p:spPr>
+          <a:xfrm>
+            <a:off x="548640" y="1737360"/>
+            <a:ext cx="6766560" cy="4114800"/>
+          </a:xfrm>
+          <a:prstGeom prst="rect">
+            <a:avLst/>
+          </a:prstGeom>
+          <a:noFill/>
+        </p:spPr>
+        <p:txBody>
+          <a:bodyPr wrap="square">
+            <a:spAutoFit/>
+          </a:bodyPr>
+          <a:lstStyle/>
+          <a:p>
+            <a:pPr>
+              <a:spcAft>
+                <a:spcPts val="1200"/>
+              </a:spcAft>
+            </a:pPr>
+            <a:r>
+              <a:rPr sz="1800" b="1">
+                <a:solidFill>
+                  <a:srgbClr val="36B5FF"/>
+                </a:solidFill>
+                <a:latin typeface="Century Gothic"/>
+              </a:rPr>
+              <a:t>✓  </a:t>
+            </a:r>
+            <a:r>
+              <a:rPr sz="1800" b="0">
+                <a:solidFill>
+                  <a:srgbClr val="FFFFFF"/>
+                </a:solidFill>
+                <a:latin typeface="Century Gothic"/>
+              </a:rPr>
+              <a:t>Clase </a:t>
+            </a:r>
+            <a:r>
+              <a:rPr sz="1800" b="0">
+                <a:solidFill>
+                  <a:srgbClr val="36B5FF"/>
+                </a:solidFill>
+                <a:latin typeface="Consolas"/>
+              </a:rPr>
+              <a:t>Producto</a:t>
+            </a:r>
+            <a:r>
+              <a:rPr sz="1800" b="0">
+                <a:solidFill>
+                  <a:srgbClr val="FFFFFF"/>
+                </a:solidFill>
+                <a:latin typeface="Century Gothic"/>
+              </a:rPr>
+              <a:t> con precio privado que no acepta negativos.</a:t>
+            </a:r>
+          </a:p>
+          <a:p>
+            <a:pPr>
+              <a:spcAft>
+                <a:spcPts val="1200"/>
+              </a:spcAft>
+            </a:pPr>
+            <a:r>
+              <a:rPr sz="1800" b="1">
+                <a:solidFill>
+                  <a:srgbClr val="36B5FF"/>
+                </a:solidFill>
+                <a:latin typeface="Century Gothic"/>
+              </a:rPr>
+              <a:t>✓  </a:t>
+            </a:r>
+            <a:r>
+              <a:rPr sz="1800" b="0">
+                <a:solidFill>
+                  <a:srgbClr val="FFFFFF"/>
+                </a:solidFill>
+                <a:latin typeface="Century Gothic"/>
+              </a:rPr>
+              <a:t>Descuento con </a:t>
+            </a:r>
+            <a:r>
+              <a:rPr sz="1800" b="0">
+                <a:solidFill>
+                  <a:srgbClr val="36B5FF"/>
+                </a:solidFill>
+                <a:latin typeface="Consolas"/>
+              </a:rPr>
+              <a:t>if</a:t>
+            </a:r>
+            <a:r>
+              <a:rPr sz="1800" b="0">
+                <a:solidFill>
+                  <a:srgbClr val="FFFFFF"/>
+                </a:solidFill>
+                <a:latin typeface="Century Gothic"/>
+              </a:rPr>
+              <a:t>.</a:t>
+            </a:r>
+          </a:p>
+          <a:p>
+            <a:pPr>
+              <a:spcAft>
+                <a:spcPts val="1200"/>
+              </a:spcAft>
+            </a:pPr>
+            <a:r>
+              <a:rPr sz="1800" b="1">
+                <a:solidFill>
+                  <a:srgbClr val="36B5FF"/>
+                </a:solidFill>
+                <a:latin typeface="Century Gothic"/>
+              </a:rPr>
+              <a:t>✓  </a:t>
+            </a:r>
+            <a:r>
+              <a:rPr sz="1800" b="0">
+                <a:solidFill>
+                  <a:srgbClr val="36B5FF"/>
+                </a:solidFill>
+                <a:latin typeface="Consolas"/>
+              </a:rPr>
+              <a:t>ProductoEnOferta</a:t>
+            </a:r>
+            <a:r>
+              <a:rPr sz="1800" b="0">
+                <a:solidFill>
+                  <a:srgbClr val="FFFFFF"/>
+                </a:solidFill>
+                <a:latin typeface="Century Gothic"/>
+              </a:rPr>
+              <a:t> que hereda y sobrescribe.</a:t>
+            </a:r>
+          </a:p>
+          <a:p>
+            <a:pPr>
+              <a:spcAft>
+                <a:spcPts val="1200"/>
+              </a:spcAft>
+            </a:pPr>
+            <a:r>
+              <a:rPr sz="1800" b="1">
+                <a:solidFill>
+                  <a:srgbClr val="36B5FF"/>
+                </a:solidFill>
+                <a:latin typeface="Century Gothic"/>
+              </a:rPr>
+              <a:t>✓  </a:t>
+            </a:r>
+            <a:r>
+              <a:rPr sz="1800" b="0">
+                <a:solidFill>
+                  <a:srgbClr val="FFFFFF"/>
+                </a:solidFill>
+                <a:latin typeface="Century Gothic"/>
+              </a:rPr>
+              <a:t>Clase </a:t>
+            </a:r>
+            <a:r>
+              <a:rPr sz="1800" b="0">
+                <a:solidFill>
+                  <a:srgbClr val="36B5FF"/>
+                </a:solidFill>
+                <a:latin typeface="Consolas"/>
+              </a:rPr>
+              <a:t>Tienda</a:t>
+            </a:r>
+            <a:r>
+              <a:rPr sz="1800" b="0">
+                <a:solidFill>
+                  <a:srgbClr val="FFFFFF"/>
+                </a:solidFill>
+                <a:latin typeface="Century Gothic"/>
+              </a:rPr>
+              <a:t> que imprime 4 casos con </a:t>
+            </a:r>
+            <a:r>
+              <a:rPr sz="1800" b="0">
+                <a:solidFill>
+                  <a:srgbClr val="36B5FF"/>
+                </a:solidFill>
+                <a:latin typeface="Consolas"/>
+              </a:rPr>
+              <a:t>gradle run</a:t>
+            </a:r>
+            <a:r>
+              <a:rPr sz="1800" b="0">
+                <a:solidFill>
+                  <a:srgbClr val="FFFFFF"/>
+                </a:solidFill>
+                <a:latin typeface="Century Gothic"/>
+              </a:rPr>
+              <a:t>.</a:t>
+            </a:r>
+          </a:p>
+        </p:txBody>
+      </p:sp>
+      <p:sp>
+        <p:nvSpPr>
+          <p:cNvPr id="5" name="Rounded Rectangle 4"/>
+          <p:cNvSpPr/>
+          <p:nvPr/>
+        </p:nvSpPr>
+        <p:spPr>
+          <a:xfrm>
+            <a:off x="7680960" y="1737360"/>
+            <a:ext cx="3962095" cy="3931920"/>
+          </a:xfrm>
+          <a:prstGeom prst="roundRect">
+            <a:avLst>
+              <a:gd name="adj" fmla="val 6000"/>
+            </a:avLst>
+          </a:prstGeom>
+          <a:solidFill>
+            <a:srgbClr val="0B2C59"/>
+          </a:solidFill>
+          <a:ln w="15875">
+            <a:solidFill>
+              <a:srgbClr val="5EA7D8"/>
+            </a:solidFill>
+          </a:ln>
+        </p:spPr>
+        <p:style>
+          <a:lnRef idx="1">
+            <a:schemeClr val="accent1"/>
+          </a:lnRef>
+          <a:fillRef idx="3">
+            <a:schemeClr val="accent1"/>
+          </a:fillRef>
+          <a:effectRef idx="2">
+            <a:schemeClr val="accent1"/>
+          </a:effectRef>
+          <a:fontRef idx="minor">
+            <a:schemeClr val="lt1"/>
+          </a:fontRef>
+        </p:style>
+        <p:txBody>
+          <a:bodyPr rtlCol="0" anchor="ctr"/>
+          <a:lstStyle/>
+          <a:p>
+            <a:endParaRPr/>
+          </a:p>
+        </p:txBody>
+      </p:sp>
+      <p:sp>
+        <p:nvSpPr>
+          <p:cNvPr id="6" name="TextBox 5"/>
+          <p:cNvSpPr txBox="1"/>
+          <p:nvPr/>
+        </p:nvSpPr>
+        <p:spPr>
+          <a:xfrm>
+            <a:off x="7909560" y="1965960"/>
+            <a:ext cx="3504895" cy="548640"/>
+          </a:xfrm>
+          <a:prstGeom prst="rect">
+            <a:avLst/>
+          </a:prstGeom>
+          <a:noFill/>
+        </p:spPr>
+        <p:txBody>
+          <a:bodyPr wrap="square" lIns="0" rIns="0" anchor="t">
+            <a:spAutoFit/>
+          </a:bodyPr>
+          <a:lstStyle/>
+          <a:p>
+            <a:pPr algn="l"/>
+            <a:r>
+              <a:rPr sz="1800" b="1">
+                <a:solidFill>
+                  <a:srgbClr val="FFFFFF"/>
+                </a:solidFill>
+                <a:latin typeface="Century Gothic"/>
+              </a:rPr>
+              <a:t>Entrega</a:t>
+            </a:r>
+          </a:p>
+        </p:txBody>
+      </p:sp>
+      <p:sp>
+        <p:nvSpPr>
+          <p:cNvPr id="7" name="TextBox 6"/>
+          <p:cNvSpPr txBox="1"/>
+          <p:nvPr/>
+        </p:nvSpPr>
+        <p:spPr>
+          <a:xfrm>
+            <a:off x="7909560" y="2468880"/>
+            <a:ext cx="3504895" cy="3017520"/>
+          </a:xfrm>
+          <a:prstGeom prst="rect">
+            <a:avLst/>
+          </a:prstGeom>
+          <a:noFill/>
+        </p:spPr>
+        <p:txBody>
+          <a:bodyPr wrap="square" lIns="0" rIns="0" anchor="t">
+            <a:spAutoFit/>
+          </a:bodyPr>
+          <a:lstStyle/>
+          <a:p>
+            <a:pPr algn="l"/>
+            <a:r>
+              <a:rPr sz="1400" b="0">
+                <a:solidFill>
+                  <a:srgbClr val="C9D6E3"/>
+                </a:solidFill>
+                <a:latin typeface="Century Gothic"/>
+              </a:rPr>
+              <a:t>Miércoles 23 de septiembre de 2026, 8:00 a.m.</a:t>
+            </a:r>
+          </a:p>
+          <a:p>
+            <a:pPr algn="l"/>
+            <a:r>
+              <a:rPr sz="1400" b="0">
+                <a:solidFill>
+                  <a:srgbClr val="C9D6E3"/>
+                </a:solidFill>
+                <a:latin typeface="Century Gothic"/>
+              </a:rPr>
+              <a:t>Repositorio en GitHub o .zip sin la carpeta build</a:t>
+            </a:r>
+          </a:p>
+          <a:p>
+            <a:pPr algn="l"/>
+            <a:r>
+              <a:rPr sz="1400" b="0">
+                <a:solidFill>
+                  <a:srgbClr val="C9D6E3"/>
+                </a:solidFill>
+                <a:latin typeface="Century Gothic"/>
+              </a:rPr>
+              <a:t>Captura de </a:t>
+            </a:r>
+            <a:r>
+              <a:rPr sz="1400" b="0">
+                <a:solidFill>
+                  <a:srgbClr val="36B5FF"/>
+                </a:solidFill>
+                <a:latin typeface="Consolas"/>
+              </a:rPr>
+              <a:t>gradle run</a:t>
+            </a:r>
+            <a:r>
+              <a:rPr sz="1400" b="0">
+                <a:solidFill>
+                  <a:srgbClr val="C9D6E3"/>
+                </a:solidFill>
+                <a:latin typeface="Century Gothic"/>
+              </a:rPr>
+              <a:t> con la salida</a:t>
+            </a:r>
+          </a:p>
+        </p:txBody>
+      </p:sp>
+      <p:sp>
+        <p:nvSpPr>
+          <p:cNvPr id="8" name="TextBox 7"/>
+          <p:cNvSpPr txBox="1"/>
+          <p:nvPr/>
+        </p:nvSpPr>
+        <p:spPr>
+          <a:xfrm>
+            <a:off x="548640" y="6400800"/>
+            <a:ext cx="8229600" cy="274320"/>
+          </a:xfrm>
+          <a:prstGeom prst="rect">
+            <a:avLst/>
+          </a:prstGeom>
+          <a:noFill/>
+        </p:spPr>
+        <p:txBody>
+          <a:bodyPr wrap="square" lIns="0" rIns="0" anchor="t">
+            <a:spAutoFit/>
+          </a:bodyPr>
+          <a:lstStyle/>
+          <a:p>
+            <a:pPr algn="l"/>
+            <a:r>
+              <a:rPr sz="1200" b="0">
+                <a:solidFill>
+                  <a:srgbClr val="C9D6E3"/>
+                </a:solidFill>
+                <a:latin typeface="Century Gothic"/>
+              </a:rPr>
+              <a:t>Semillero QA 2026 · Automatización Web · Clase 1 · 01-fundamentos-java-poo</a:t>
+            </a:r>
+          </a:p>
+        </p:txBody>
+      </p:sp>
+      <p:sp>
+        <p:nvSpPr>
+          <p:cNvPr id="9" name="TextBox 8"/>
+          <p:cNvSpPr txBox="1"/>
+          <p:nvPr/>
+        </p:nvSpPr>
+        <p:spPr>
+          <a:xfrm>
+            <a:off x="10728655" y="6400800"/>
+            <a:ext cx="914400" cy="274320"/>
+          </a:xfrm>
+          <a:prstGeom prst="rect">
+            <a:avLst/>
+          </a:prstGeom>
+          <a:noFill/>
+        </p:spPr>
+        <p:txBody>
+          <a:bodyPr wrap="square" lIns="0" rIns="0" anchor="t">
+            <a:spAutoFit/>
+          </a:bodyPr>
+          <a:lstStyle/>
+          <a:p>
+            <a:pPr algn="r"/>
+            <a:r>
+              <a:rPr sz="1200" b="0">
+                <a:solidFill>
+                  <a:srgbClr val="C9D6E3"/>
+                </a:solidFill>
+                <a:latin typeface="Century Gothic"/>
+              </a:rPr>
+              <a:t>12</a:t>
+            </a:r>
+          </a:p>
+        </p:txBody>
+      </p:sp>
+    </p:spTree>
+  </p:cSld>
+  <p:clrMapOvr>
+    <a:masterClrMapping/>
+  </p:clrMapOvr>
+</p:sld>
+</file>
+
+<file path=ppt/slides/slide12.xml><?xml version="1.0" encoding="utf-8"?>
 <p:sld xmlns:a="http://schemas.openxmlformats.org/drawingml/2006/main" xmlns:p="http://schemas.openxmlformats.org/presentationml/2006/main" xmlns:r="http://schemas.openxmlformats.org/officeDocument/2006/relationships">
   <p:cSld>
     <p:bg>
@@ -3988,7 +4846,7 @@
                 </a:solidFill>
                 <a:latin typeface="Century Gothic"/>
               </a:rPr>
-              <a:t>Polimorfismo: métodos sobrecargados</a:t>
+              <a:t>Heredar o firmar un compromiso</a:t>
             </a:r>
           </a:p>
         </p:txBody>
@@ -4002,7 +4860,7 @@
         <p:spPr>
           <a:xfrm>
             <a:off x="548640" y="1737360"/>
-            <a:ext cx="6949440" cy="4389120"/>
+            <a:ext cx="5669280" cy="4389120"/>
           </a:xfrm>
           <a:prstGeom prst="roundRect">
             <a:avLst>
@@ -4085,7 +4943,7 @@
         <p:spPr>
           <a:xfrm>
             <a:off x="777240" y="2194560"/>
-            <a:ext cx="6492240" cy="3840480"/>
+            <a:ext cx="5212080" cy="3840480"/>
           </a:xfrm>
           <a:prstGeom prst="rect">
             <a:avLst/>
@@ -4105,7 +4963,7 @@
                 </a:solidFill>
                 <a:latin typeface="Consolas"/>
               </a:rPr>
-              <a:t>public class Calculadora {</a:t>
+              <a:t>public interface Volador {</a:t>
             </a:r>
           </a:p>
           <a:p>
@@ -4116,7 +4974,7 @@
                 </a:solidFill>
                 <a:latin typeface="Consolas"/>
               </a:rPr>
-              <a:t>    public int sumar(int a, int b) {</a:t>
+              <a:t>    String volar();</a:t>
             </a:r>
           </a:p>
           <a:p>
@@ -4127,7 +4985,7 @@
                 </a:solidFill>
                 <a:latin typeface="Consolas"/>
               </a:rPr>
-              <a:t>        return a + b;</a:t>
+              <a:t>}</a:t>
             </a:r>
           </a:p>
           <a:p>
@@ -4138,6 +4996,61 @@
                 </a:solidFill>
                 <a:latin typeface="Consolas"/>
               </a:rPr>
+              <a:t> </a:t>
+            </a:r>
+          </a:p>
+          <a:p>
+            <a:r>
+              <a:rPr sz="1300">
+                <a:solidFill>
+                  <a:srgbClr val="FFFFFF"/>
+                </a:solidFill>
+                <a:latin typeface="Consolas"/>
+              </a:rPr>
+              <a:t>public class Pajaro implements Volador {</a:t>
+            </a:r>
+          </a:p>
+          <a:p>
+            <a:r>
+              <a:rPr sz="1300">
+                <a:solidFill>
+                  <a:srgbClr val="FFFFFF"/>
+                </a:solidFill>
+                <a:latin typeface="Consolas"/>
+              </a:rPr>
+              <a:t>    @Override</a:t>
+            </a:r>
+          </a:p>
+          <a:p>
+            <a:r>
+              <a:rPr sz="1300">
+                <a:solidFill>
+                  <a:srgbClr val="FFFFFF"/>
+                </a:solidFill>
+                <a:latin typeface="Consolas"/>
+              </a:rPr>
+              <a:t>    public String volar() {</a:t>
+            </a:r>
+          </a:p>
+          <a:p>
+            <a:r>
+              <a:rPr sz="1300">
+                <a:solidFill>
+                  <a:srgbClr val="FFFFFF"/>
+                </a:solidFill>
+                <a:latin typeface="Consolas"/>
+              </a:rPr>
+              <a:t>        return "vuela moviendo las alas";</a:t>
+            </a:r>
+          </a:p>
+          <a:p>
+            <a:r>
+              <a:rPr sz="1300">
+                <a:solidFill>
+                  <a:srgbClr val="FFFFFF"/>
+                </a:solidFill>
+                <a:latin typeface="Consolas"/>
+              </a:rPr>
               <a:t>    }</a:t>
             </a:r>
           </a:p>
@@ -4149,7 +5062,7 @@
                 </a:solidFill>
                 <a:latin typeface="Consolas"/>
               </a:rPr>
-              <a:t>    public int sumar(int a, int b, int c) {</a:t>
+              <a:t>}</a:t>
             </a:r>
           </a:p>
           <a:p>
@@ -4160,7 +5073,7 @@
                 </a:solidFill>
                 <a:latin typeface="Consolas"/>
               </a:rPr>
-              <a:t>        return a + b + c;</a:t>
+              <a:t> </a:t>
             </a:r>
           </a:p>
           <a:p>
@@ -4171,7 +5084,7 @@
                 </a:solidFill>
                 <a:latin typeface="Consolas"/>
               </a:rPr>
-              <a:t>    }</a:t>
+              <a:t>public class Perro extends Animal {</a:t>
             </a:r>
           </a:p>
           <a:p>
@@ -4182,7 +5095,7 @@
                 </a:solidFill>
                 <a:latin typeface="Consolas"/>
               </a:rPr>
-              <a:t>    public double sumar(double a, double b) {</a:t>
+              <a:t>    ...</a:t>
             </a:r>
           </a:p>
           <a:p>
@@ -4193,189 +5106,7 @@
                 </a:solidFill>
                 <a:latin typeface="Consolas"/>
               </a:rPr>
-              <a:t>        return a + b;</a:t>
-            </a:r>
-          </a:p>
-          <a:p>
-            <a:r>
-              <a:rPr sz="1300">
-                <a:solidFill>
-                  <a:srgbClr val="FFFFFF"/>
-                </a:solidFill>
-                <a:latin typeface="Consolas"/>
-              </a:rPr>
-              <a:t>    }</a:t>
-            </a:r>
-          </a:p>
-          <a:p>
-            <a:r>
-              <a:rPr sz="1300">
-                <a:solidFill>
-                  <a:srgbClr val="FFFFFF"/>
-                </a:solidFill>
-                <a:latin typeface="Consolas"/>
-              </a:rPr>
               <a:t>}</a:t>
-            </a:r>
-          </a:p>
-          <a:p>
-            <a:r>
-              <a:rPr sz="1300">
-                <a:solidFill>
-                  <a:srgbClr val="FFFFFF"/>
-                </a:solidFill>
-                <a:latin typeface="Consolas"/>
-              </a:rPr>
-              <a:t> </a:t>
-            </a:r>
-          </a:p>
-          <a:p>
-            <a:r>
-              <a:rPr sz="1300">
-                <a:solidFill>
-                  <a:srgbClr val="FFFFFF"/>
-                </a:solidFill>
-                <a:latin typeface="Consolas"/>
-              </a:rPr>
-              <a:t>calculadora.sumar(2, 3)       // 5</a:t>
-            </a:r>
-          </a:p>
-          <a:p>
-            <a:r>
-              <a:rPr sz="1300">
-                <a:solidFill>
-                  <a:srgbClr val="FFFFFF"/>
-                </a:solidFill>
-                <a:latin typeface="Consolas"/>
-              </a:rPr>
-              <a:t>calculadora.sumar(2, 3, 4)    // 9</a:t>
-            </a:r>
-          </a:p>
-          <a:p>
-            <a:r>
-              <a:rPr sz="1300">
-                <a:solidFill>
-                  <a:srgbClr val="FFFFFF"/>
-                </a:solidFill>
-                <a:latin typeface="Consolas"/>
-              </a:rPr>
-              <a:t>calculadora.sumar(2.5, 1.5)   // 4.0</a:t>
-            </a:r>
-          </a:p>
-        </p:txBody>
-      </p:sp>
-      <p:sp>
-        <p:nvSpPr>
-          <p:cNvPr id="7" name="TextBox 6"/>
-          <p:cNvSpPr txBox="1"/>
-          <p:nvPr/>
-        </p:nvSpPr>
-        <p:spPr>
-          <a:xfrm>
-            <a:off x="7863840" y="1737360"/>
-            <a:ext cx="3779215" cy="4389120"/>
-          </a:xfrm>
-          <a:prstGeom prst="rect">
-            <a:avLst/>
-          </a:prstGeom>
-          <a:noFill/>
-        </p:spPr>
-        <p:txBody>
-          <a:bodyPr wrap="square">
-            <a:spAutoFit/>
-          </a:bodyPr>
-          <a:lstStyle/>
-          <a:p>
-            <a:pPr>
-              <a:spcAft>
-                <a:spcPts val="1000"/>
-              </a:spcAft>
-            </a:pPr>
-            <a:r>
-              <a:rPr sz="1600" b="1">
-                <a:solidFill>
-                  <a:srgbClr val="36B5FF"/>
-                </a:solidFill>
-                <a:latin typeface="Century Gothic"/>
-              </a:rPr>
-              <a:t>▸  </a:t>
-            </a:r>
-            <a:r>
-              <a:rPr sz="1600" b="0">
-                <a:solidFill>
-                  <a:srgbClr val="FFFFFF"/>
-                </a:solidFill>
-                <a:latin typeface="Century Gothic"/>
-              </a:rPr>
-              <a:t>Mismo nombre, datos distintos.</a:t>
-            </a:r>
-          </a:p>
-          <a:p>
-            <a:pPr>
-              <a:spcAft>
-                <a:spcPts val="1000"/>
-              </a:spcAft>
-            </a:pPr>
-            <a:r>
-              <a:rPr sz="1600" b="1">
-                <a:solidFill>
-                  <a:srgbClr val="36B5FF"/>
-                </a:solidFill>
-                <a:latin typeface="Century Gothic"/>
-              </a:rPr>
-              <a:t>▸  </a:t>
-            </a:r>
-            <a:r>
-              <a:rPr sz="1600" b="0">
-                <a:solidFill>
-                  <a:srgbClr val="FFFFFF"/>
-                </a:solidFill>
-                <a:latin typeface="Century Gothic"/>
-              </a:rPr>
-              <a:t>Java escoge cuál usar por la cantidad y el tipo de datos.</a:t>
-            </a:r>
-          </a:p>
-          <a:p>
-            <a:pPr>
-              <a:spcAft>
-                <a:spcPts val="1000"/>
-              </a:spcAft>
-            </a:pPr>
-            <a:r>
-              <a:rPr sz="1600" b="1">
-                <a:solidFill>
-                  <a:srgbClr val="36B5FF"/>
-                </a:solidFill>
-                <a:latin typeface="Century Gothic"/>
-              </a:rPr>
-              <a:t>▸  </a:t>
-            </a:r>
-            <a:r>
-              <a:rPr sz="1600" b="0">
-                <a:solidFill>
-                  <a:srgbClr val="FFFFFF"/>
-                </a:solidFill>
-                <a:latin typeface="Century Gothic"/>
-              </a:rPr>
-              <a:t>No es </a:t>
-            </a:r>
-            <a:r>
-              <a:rPr sz="1600" b="0">
-                <a:solidFill>
-                  <a:srgbClr val="36B5FF"/>
-                </a:solidFill>
-                <a:latin typeface="Consolas"/>
-              </a:rPr>
-              <a:t>@Override</a:t>
-            </a:r>
-            <a:r>
-              <a:rPr sz="1600" b="0">
-                <a:solidFill>
-                  <a:srgbClr val="FFFFFF"/>
-                </a:solidFill>
-                <a:latin typeface="Century Gothic"/>
-              </a:rPr>
-              <a:t>: sobrescribir es cambiar un método del padre.</a:t>
             </a:r>
           </a:p>
         </p:txBody>
@@ -4450,6 +5181,317 @@
           </a:p>
         </p:txBody>
       </p:sp>
+      <p:graphicFrame>
+        <p:nvGraphicFramePr>
+          <p:cNvPr id="10" name="Table 9"/>
+          <p:cNvGraphicFramePr>
+            <a:graphicFrameLocks noGrp="1"/>
+          </p:cNvGraphicFramePr>
+          <p:nvPr/>
+        </p:nvGraphicFramePr>
+        <p:xfrm>
+          <a:off x="6492240" y="1920240"/>
+          <a:ext cx="5148070" cy="3291840"/>
+        </p:xfrm>
+        <a:graphic>
+          <a:graphicData uri="http://schemas.openxmlformats.org/drawingml/2006/table">
+            <a:tbl>
+              <a:tblPr firstRow="1" bandRow="1">
+                <a:tableStyleId>{5C22544A-7EE6-4342-B048-85BDC9FD1C3A}</a:tableStyleId>
+              </a:tblPr>
+              <a:tblGrid>
+                <a:gridCol w="1325880"/>
+                <a:gridCol w="1911095"/>
+                <a:gridCol w="1911095"/>
+              </a:tblGrid>
+              <a:tr h="822960">
+                <a:tc>
+                  <a:txBody>
+                    <a:bodyPr wrap="square"/>
+                    <a:lstStyle/>
+                    <a:p>
+                      <a:pPr algn="l"/>
+                      <a:r>
+                        <a:rPr sz="1400" b="1">
+                          <a:solidFill>
+                            <a:srgbClr val="FFFFFF"/>
+                          </a:solidFill>
+                          <a:latin typeface="Century Gothic"/>
+                        </a:rPr>
+                        <a:t/>
+                      </a:r>
+                    </a:p>
+                  </a:txBody>
+                  <a:tcPr marL="91440" marR="91440">
+                    <a:solidFill>
+                      <a:srgbClr val="0072BC"/>
+                    </a:solidFill>
+                  </a:tcPr>
+                </a:tc>
+                <a:tc>
+                  <a:txBody>
+                    <a:bodyPr wrap="square"/>
+                    <a:lstStyle/>
+                    <a:p>
+                      <a:pPr algn="l"/>
+                      <a:r>
+                        <a:rPr sz="1400" b="1">
+                          <a:solidFill>
+                            <a:srgbClr val="FFFFFF"/>
+                          </a:solidFill>
+                          <a:latin typeface="Consolas"/>
+                        </a:rPr>
+                        <a:t>extends</a:t>
+                      </a:r>
+                    </a:p>
+                  </a:txBody>
+                  <a:tcPr marL="91440" marR="91440">
+                    <a:solidFill>
+                      <a:srgbClr val="0072BC"/>
+                    </a:solidFill>
+                  </a:tcPr>
+                </a:tc>
+                <a:tc>
+                  <a:txBody>
+                    <a:bodyPr wrap="square"/>
+                    <a:lstStyle/>
+                    <a:p>
+                      <a:pPr algn="l"/>
+                      <a:r>
+                        <a:rPr sz="1400" b="1">
+                          <a:solidFill>
+                            <a:srgbClr val="FFFFFF"/>
+                          </a:solidFill>
+                          <a:latin typeface="Consolas"/>
+                        </a:rPr>
+                        <a:t>implements</a:t>
+                      </a:r>
+                    </a:p>
+                  </a:txBody>
+                  <a:tcPr marL="91440" marR="91440">
+                    <a:solidFill>
+                      <a:srgbClr val="0072BC"/>
+                    </a:solidFill>
+                  </a:tcPr>
+                </a:tc>
+              </a:tr>
+              <a:tr h="822960">
+                <a:tc>
+                  <a:txBody>
+                    <a:bodyPr wrap="square"/>
+                    <a:lstStyle/>
+                    <a:p>
+                      <a:pPr algn="l"/>
+                      <a:r>
+                        <a:rPr sz="1400" b="1">
+                          <a:solidFill>
+                            <a:srgbClr val="FFFFFF"/>
+                          </a:solidFill>
+                          <a:latin typeface="Century Gothic"/>
+                        </a:rPr>
+                        <a:t>Qué recibe</a:t>
+                      </a:r>
+                    </a:p>
+                  </a:txBody>
+                  <a:tcPr marL="91440" marR="91440">
+                    <a:solidFill>
+                      <a:srgbClr val="0B2C59"/>
+                    </a:solidFill>
+                  </a:tcPr>
+                </a:tc>
+                <a:tc>
+                  <a:txBody>
+                    <a:bodyPr wrap="square"/>
+                    <a:lstStyle/>
+                    <a:p>
+                      <a:pPr algn="l"/>
+                      <a:r>
+                        <a:rPr sz="1400" b="0">
+                          <a:solidFill>
+                            <a:srgbClr val="FFFFFF"/>
+                          </a:solidFill>
+                          <a:latin typeface="Century Gothic"/>
+                        </a:rPr>
+                        <a:t>Código ya hecho del padre</a:t>
+                      </a:r>
+                    </a:p>
+                  </a:txBody>
+                  <a:tcPr marL="91440" marR="91440">
+                    <a:solidFill>
+                      <a:srgbClr val="0B2C59"/>
+                    </a:solidFill>
+                  </a:tcPr>
+                </a:tc>
+                <a:tc>
+                  <a:txBody>
+                    <a:bodyPr wrap="square"/>
+                    <a:lstStyle/>
+                    <a:p>
+                      <a:pPr algn="l"/>
+                      <a:r>
+                        <a:rPr sz="1400" b="0">
+                          <a:solidFill>
+                            <a:srgbClr val="FFFFFF"/>
+                          </a:solidFill>
+                          <a:latin typeface="Century Gothic"/>
+                        </a:rPr>
+                        <a:t>La obligación de escribirlo</a:t>
+                      </a:r>
+                    </a:p>
+                  </a:txBody>
+                  <a:tcPr marL="91440" marR="91440">
+                    <a:solidFill>
+                      <a:srgbClr val="0B2C59"/>
+                    </a:solidFill>
+                  </a:tcPr>
+                </a:tc>
+              </a:tr>
+              <a:tr h="822960">
+                <a:tc>
+                  <a:txBody>
+                    <a:bodyPr wrap="square"/>
+                    <a:lstStyle/>
+                    <a:p>
+                      <a:pPr algn="l"/>
+                      <a:r>
+                        <a:rPr sz="1400" b="1">
+                          <a:solidFill>
+                            <a:srgbClr val="FFFFFF"/>
+                          </a:solidFill>
+                          <a:latin typeface="Century Gothic"/>
+                        </a:rPr>
+                        <a:t>Cuántas</a:t>
+                      </a:r>
+                    </a:p>
+                  </a:txBody>
+                  <a:tcPr marL="91440" marR="91440">
+                    <a:solidFill>
+                      <a:srgbClr val="08264F"/>
+                    </a:solidFill>
+                  </a:tcPr>
+                </a:tc>
+                <a:tc>
+                  <a:txBody>
+                    <a:bodyPr wrap="square"/>
+                    <a:lstStyle/>
+                    <a:p>
+                      <a:pPr algn="l"/>
+                      <a:r>
+                        <a:rPr sz="1400" b="0">
+                          <a:solidFill>
+                            <a:srgbClr val="FFFFFF"/>
+                          </a:solidFill>
+                          <a:latin typeface="Century Gothic"/>
+                        </a:rPr>
+                        <a:t>Una sola clase padre</a:t>
+                      </a:r>
+                    </a:p>
+                  </a:txBody>
+                  <a:tcPr marL="91440" marR="91440">
+                    <a:solidFill>
+                      <a:srgbClr val="08264F"/>
+                    </a:solidFill>
+                  </a:tcPr>
+                </a:tc>
+                <a:tc>
+                  <a:txBody>
+                    <a:bodyPr wrap="square"/>
+                    <a:lstStyle/>
+                    <a:p>
+                      <a:pPr algn="l"/>
+                      <a:r>
+                        <a:rPr sz="1400" b="0">
+                          <a:solidFill>
+                            <a:srgbClr val="FFFFFF"/>
+                          </a:solidFill>
+                          <a:latin typeface="Century Gothic"/>
+                        </a:rPr>
+                        <a:t>Varias interfaces</a:t>
+                      </a:r>
+                    </a:p>
+                  </a:txBody>
+                  <a:tcPr marL="91440" marR="91440">
+                    <a:solidFill>
+                      <a:srgbClr val="08264F"/>
+                    </a:solidFill>
+                  </a:tcPr>
+                </a:tc>
+              </a:tr>
+              <a:tr h="822960">
+                <a:tc>
+                  <a:txBody>
+                    <a:bodyPr wrap="square"/>
+                    <a:lstStyle/>
+                    <a:p>
+                      <a:pPr algn="l"/>
+                      <a:r>
+                        <a:rPr sz="1400" b="1">
+                          <a:solidFill>
+                            <a:srgbClr val="FFFFFF"/>
+                          </a:solidFill>
+                          <a:latin typeface="Century Gothic"/>
+                        </a:rPr>
+                        <a:t>En el proyecto</a:t>
+                      </a:r>
+                    </a:p>
+                  </a:txBody>
+                  <a:tcPr marL="91440" marR="91440">
+                    <a:solidFill>
+                      <a:srgbClr val="0B2C59"/>
+                    </a:solidFill>
+                  </a:tcPr>
+                </a:tc>
+                <a:tc>
+                  <a:txBody>
+                    <a:bodyPr wrap="square"/>
+                    <a:lstStyle/>
+                    <a:p>
+                      <a:pPr algn="l"/>
+                      <a:r>
+                        <a:rPr sz="1400" b="0">
+                          <a:solidFill>
+                            <a:srgbClr val="FFFFFF"/>
+                          </a:solidFill>
+                          <a:latin typeface="Century Gothic"/>
+                        </a:rPr>
+                        <a:t>Perro y Animal</a:t>
+                      </a:r>
+                    </a:p>
+                  </a:txBody>
+                  <a:tcPr marL="91440" marR="91440">
+                    <a:solidFill>
+                      <a:srgbClr val="0B2C59"/>
+                    </a:solidFill>
+                  </a:tcPr>
+                </a:tc>
+                <a:tc>
+                  <a:txBody>
+                    <a:bodyPr wrap="square"/>
+                    <a:lstStyle/>
+                    <a:p>
+                      <a:pPr algn="l"/>
+                      <a:r>
+                        <a:rPr sz="1400" b="0">
+                          <a:solidFill>
+                            <a:srgbClr val="FFFFFF"/>
+                          </a:solidFill>
+                          <a:latin typeface="Century Gothic"/>
+                        </a:rPr>
+                        <a:t>Pajaro y Volador</a:t>
+                      </a:r>
+                    </a:p>
+                  </a:txBody>
+                  <a:tcPr marL="91440" marR="91440">
+                    <a:solidFill>
+                      <a:srgbClr val="0B2C59"/>
+                    </a:solidFill>
+                  </a:tcPr>
+                </a:tc>
+              </a:tr>
+            </a:tbl>
+          </a:graphicData>
+        </a:graphic>
+      </p:graphicFrame>
     </p:spTree>
   </p:cSld>
   <p:clrMapOvr>
@@ -9150,7 +10192,7 @@
 </file>
 
 <file path=ppt/slides/slide9.xml><?xml version="1.0" encoding="utf-8"?>
-<p:sld xmlns:a="http://schemas.openxmlformats.org/drawingml/2006/main" xmlns:r="http://schemas.openxmlformats.org/officeDocument/2006/relationships" xmlns:p="http://schemas.openxmlformats.org/presentationml/2006/main">
+<p:sld xmlns:a="http://schemas.openxmlformats.org/drawingml/2006/main" xmlns:p="http://schemas.openxmlformats.org/presentationml/2006/main" xmlns:r="http://schemas.openxmlformats.org/officeDocument/2006/relationships">
   <p:cSld>
     <p:bg>
       <p:bgPr>
@@ -9166,14 +10208,7 @@
         <p:cNvGrpSpPr/>
         <p:nvPr/>
       </p:nvGrpSpPr>
-      <p:grpSpPr>
-        <a:xfrm>
-          <a:off x="0" y="0"/>
-          <a:ext cx="0" cy="0"/>
-          <a:chOff x="0" y="0"/>
-          <a:chExt cx="0" cy="0"/>
-        </a:xfrm>
-      </p:grpSpPr>
+      <p:grpSpPr/>
       <p:sp>
         <p:nvSpPr>
           <p:cNvPr id="2" name="Rounded Rectangle 1"/>
@@ -9183,7 +10218,7 @@
         <p:spPr>
           <a:xfrm>
             <a:off x="548640" y="411480"/>
-            <a:ext cx="1362456" cy="329184"/>
+            <a:ext cx="1124712" cy="329184"/>
           </a:xfrm>
           <a:prstGeom prst="roundRect">
             <a:avLst>
@@ -9223,7 +10258,7 @@
                 </a:solidFill>
                 <a:latin typeface="Century Gothic"/>
               </a:rPr>
-              <a:t>PRÁCTICA</a:t>
+              <a:t>TEMA 3</a:t>
             </a:r>
           </a:p>
         </p:txBody>
@@ -9258,7 +10293,7 @@
                 </a:solidFill>
                 <a:latin typeface="Century Gothic"/>
               </a:rPr>
-              <a:t>Cómo lo corres y cómo lees un error</a:t>
+              <a:t>Polimorfismo: métodos sobrecargados</a:t>
             </a:r>
           </a:p>
         </p:txBody>
@@ -9271,18 +10306,18 @@
         </p:nvSpPr>
         <p:spPr>
           <a:xfrm>
-            <a:off x="548640" y="2057400"/>
-            <a:ext cx="2464993" cy="2651760"/>
+            <a:off x="548640" y="1737360"/>
+            <a:ext cx="6949440" cy="4389120"/>
           </a:xfrm>
           <a:prstGeom prst="roundRect">
             <a:avLst>
-              <a:gd name="adj" fmla="val 6000"/>
+              <a:gd name="adj" fmla="val 3000"/>
             </a:avLst>
           </a:prstGeom>
           <a:solidFill>
-            <a:srgbClr val="0B2C59"/>
+            <a:srgbClr val="0A1B33"/>
           </a:solidFill>
-          <a:ln w="15875">
+          <a:ln w="12700">
             <a:solidFill>
               <a:srgbClr val="5EA7D8"/>
             </a:solidFill>
@@ -9306,6 +10341,7 @@
           <a:bodyPr rtlCol="0" anchor="ctr"/>
           <a:lstStyle/>
           <a:p>
+            <a:pPr algn="ctr"/>
             <a:endParaRPr/>
           </a:p>
         </p:txBody>
@@ -9318,8 +10354,8 @@
         </p:nvSpPr>
         <p:spPr>
           <a:xfrm>
-            <a:off x="777240" y="2286000"/>
-            <a:ext cx="2007793" cy="548640"/>
+            <a:off x="777240" y="1847088"/>
+            <a:ext cx="2743200" cy="274320"/>
           </a:xfrm>
           <a:prstGeom prst="rect">
             <a:avLst/>
@@ -9334,13 +10370,13 @@
           <a:p>
             <a:pPr algn="l"/>
             <a:r>
-              <a:rPr sz="1800" b="1">
-                <a:solidFill>
-                  <a:srgbClr val="FFFFFF"/>
-                </a:solidFill>
-                <a:latin typeface="Century Gothic"/>
-              </a:rPr>
-              <a:t>1. PowerShell</a:t>
+              <a:rPr sz="1200" b="1">
+                <a:solidFill>
+                  <a:srgbClr val="36B5FF"/>
+                </a:solidFill>
+                <a:latin typeface="Century Gothic"/>
+              </a:rPr>
+              <a:t>Java</a:t>
             </a:r>
           </a:p>
         </p:txBody>
@@ -9353,8 +10389,312 @@
         </p:nvSpPr>
         <p:spPr>
           <a:xfrm>
-            <a:off x="777240" y="2788920"/>
-            <a:ext cx="2007793" cy="1737360"/>
+            <a:off x="777240" y="2194560"/>
+            <a:ext cx="6492240" cy="3840480"/>
+          </a:xfrm>
+          <a:prstGeom prst="rect">
+            <a:avLst/>
+          </a:prstGeom>
+          <a:noFill/>
+        </p:spPr>
+        <p:txBody>
+          <a:bodyPr wrap="square">
+            <a:spAutoFit/>
+          </a:bodyPr>
+          <a:lstStyle/>
+          <a:p>
+            <a:r>
+              <a:rPr sz="1300">
+                <a:solidFill>
+                  <a:srgbClr val="FFFFFF"/>
+                </a:solidFill>
+                <a:latin typeface="Consolas"/>
+              </a:rPr>
+              <a:t>public class Calculadora {</a:t>
+            </a:r>
+          </a:p>
+          <a:p>
+            <a:r>
+              <a:rPr sz="1300">
+                <a:solidFill>
+                  <a:srgbClr val="FFFFFF"/>
+                </a:solidFill>
+                <a:latin typeface="Consolas"/>
+              </a:rPr>
+              <a:t>    public int sumar(int a, int b) {</a:t>
+            </a:r>
+          </a:p>
+          <a:p>
+            <a:r>
+              <a:rPr sz="1300">
+                <a:solidFill>
+                  <a:srgbClr val="FFFFFF"/>
+                </a:solidFill>
+                <a:latin typeface="Consolas"/>
+              </a:rPr>
+              <a:t>        return a + b;</a:t>
+            </a:r>
+          </a:p>
+          <a:p>
+            <a:r>
+              <a:rPr sz="1300">
+                <a:solidFill>
+                  <a:srgbClr val="FFFFFF"/>
+                </a:solidFill>
+                <a:latin typeface="Consolas"/>
+              </a:rPr>
+              <a:t>    }</a:t>
+            </a:r>
+          </a:p>
+          <a:p>
+            <a:r>
+              <a:rPr sz="1300">
+                <a:solidFill>
+                  <a:srgbClr val="FFFFFF"/>
+                </a:solidFill>
+                <a:latin typeface="Consolas"/>
+              </a:rPr>
+              <a:t>    public int sumar(int a, int b, int c) {</a:t>
+            </a:r>
+          </a:p>
+          <a:p>
+            <a:r>
+              <a:rPr sz="1300">
+                <a:solidFill>
+                  <a:srgbClr val="FFFFFF"/>
+                </a:solidFill>
+                <a:latin typeface="Consolas"/>
+              </a:rPr>
+              <a:t>        return a + b + c;</a:t>
+            </a:r>
+          </a:p>
+          <a:p>
+            <a:r>
+              <a:rPr sz="1300">
+                <a:solidFill>
+                  <a:srgbClr val="FFFFFF"/>
+                </a:solidFill>
+                <a:latin typeface="Consolas"/>
+              </a:rPr>
+              <a:t>    }</a:t>
+            </a:r>
+          </a:p>
+          <a:p>
+            <a:r>
+              <a:rPr sz="1300">
+                <a:solidFill>
+                  <a:srgbClr val="FFFFFF"/>
+                </a:solidFill>
+                <a:latin typeface="Consolas"/>
+              </a:rPr>
+              <a:t>    public double sumar(double a, double b) {</a:t>
+            </a:r>
+          </a:p>
+          <a:p>
+            <a:r>
+              <a:rPr sz="1300">
+                <a:solidFill>
+                  <a:srgbClr val="FFFFFF"/>
+                </a:solidFill>
+                <a:latin typeface="Consolas"/>
+              </a:rPr>
+              <a:t>        return a + b;</a:t>
+            </a:r>
+          </a:p>
+          <a:p>
+            <a:r>
+              <a:rPr sz="1300">
+                <a:solidFill>
+                  <a:srgbClr val="FFFFFF"/>
+                </a:solidFill>
+                <a:latin typeface="Consolas"/>
+              </a:rPr>
+              <a:t>    }</a:t>
+            </a:r>
+          </a:p>
+          <a:p>
+            <a:r>
+              <a:rPr sz="1300">
+                <a:solidFill>
+                  <a:srgbClr val="FFFFFF"/>
+                </a:solidFill>
+                <a:latin typeface="Consolas"/>
+              </a:rPr>
+              <a:t>}</a:t>
+            </a:r>
+          </a:p>
+          <a:p>
+            <a:r>
+              <a:rPr sz="1300">
+                <a:solidFill>
+                  <a:srgbClr val="FFFFFF"/>
+                </a:solidFill>
+                <a:latin typeface="Consolas"/>
+              </a:rPr>
+              <a:t> </a:t>
+            </a:r>
+          </a:p>
+          <a:p>
+            <a:r>
+              <a:rPr sz="1300">
+                <a:solidFill>
+                  <a:srgbClr val="FFFFFF"/>
+                </a:solidFill>
+                <a:latin typeface="Consolas"/>
+              </a:rPr>
+              <a:t>calculadora.sumar(2, 3)       // 5</a:t>
+            </a:r>
+          </a:p>
+          <a:p>
+            <a:r>
+              <a:rPr sz="1300">
+                <a:solidFill>
+                  <a:srgbClr val="FFFFFF"/>
+                </a:solidFill>
+                <a:latin typeface="Consolas"/>
+              </a:rPr>
+              <a:t>calculadora.sumar(2, 3, 4)    // 9</a:t>
+            </a:r>
+          </a:p>
+          <a:p>
+            <a:r>
+              <a:rPr sz="1300">
+                <a:solidFill>
+                  <a:srgbClr val="FFFFFF"/>
+                </a:solidFill>
+                <a:latin typeface="Consolas"/>
+              </a:rPr>
+              <a:t>calculadora.sumar(2.5, 1.5)   // 4.0</a:t>
+            </a:r>
+          </a:p>
+        </p:txBody>
+      </p:sp>
+      <p:sp>
+        <p:nvSpPr>
+          <p:cNvPr id="7" name="TextBox 6"/>
+          <p:cNvSpPr txBox="1"/>
+          <p:nvPr/>
+        </p:nvSpPr>
+        <p:spPr>
+          <a:xfrm>
+            <a:off x="7863840" y="1737360"/>
+            <a:ext cx="3779215" cy="4389120"/>
+          </a:xfrm>
+          <a:prstGeom prst="rect">
+            <a:avLst/>
+          </a:prstGeom>
+          <a:noFill/>
+        </p:spPr>
+        <p:txBody>
+          <a:bodyPr wrap="square">
+            <a:spAutoFit/>
+          </a:bodyPr>
+          <a:lstStyle/>
+          <a:p>
+            <a:pPr>
+              <a:spcAft>
+                <a:spcPts val="1000"/>
+              </a:spcAft>
+            </a:pPr>
+            <a:r>
+              <a:rPr sz="1600" b="1">
+                <a:solidFill>
+                  <a:srgbClr val="36B5FF"/>
+                </a:solidFill>
+                <a:latin typeface="Century Gothic"/>
+              </a:rPr>
+              <a:t>▸  </a:t>
+            </a:r>
+            <a:r>
+              <a:rPr sz="1600" b="0">
+                <a:solidFill>
+                  <a:srgbClr val="FFFFFF"/>
+                </a:solidFill>
+                <a:latin typeface="Century Gothic"/>
+              </a:rPr>
+              <a:t>Mismo nombre, datos distintos.</a:t>
+            </a:r>
+          </a:p>
+          <a:p>
+            <a:pPr>
+              <a:spcAft>
+                <a:spcPts val="1000"/>
+              </a:spcAft>
+            </a:pPr>
+            <a:r>
+              <a:rPr sz="1600" b="1">
+                <a:solidFill>
+                  <a:srgbClr val="36B5FF"/>
+                </a:solidFill>
+                <a:latin typeface="Century Gothic"/>
+              </a:rPr>
+              <a:t>▸  </a:t>
+            </a:r>
+            <a:r>
+              <a:rPr sz="1600" b="0">
+                <a:solidFill>
+                  <a:srgbClr val="FFFFFF"/>
+                </a:solidFill>
+                <a:latin typeface="Century Gothic"/>
+              </a:rPr>
+              <a:t>Java escoge cuál usar por la cantidad y el tipo de datos.</a:t>
+            </a:r>
+          </a:p>
+          <a:p>
+            <a:pPr>
+              <a:spcAft>
+                <a:spcPts val="1000"/>
+              </a:spcAft>
+            </a:pPr>
+            <a:r>
+              <a:rPr sz="1600" b="1">
+                <a:solidFill>
+                  <a:srgbClr val="36B5FF"/>
+                </a:solidFill>
+                <a:latin typeface="Century Gothic"/>
+              </a:rPr>
+              <a:t>▸  </a:t>
+            </a:r>
+            <a:r>
+              <a:rPr sz="1600" b="0">
+                <a:solidFill>
+                  <a:srgbClr val="FFFFFF"/>
+                </a:solidFill>
+                <a:latin typeface="Century Gothic"/>
+              </a:rPr>
+              <a:t>No es </a:t>
+            </a:r>
+            <a:r>
+              <a:rPr sz="1600" b="0">
+                <a:solidFill>
+                  <a:srgbClr val="36B5FF"/>
+                </a:solidFill>
+                <a:latin typeface="Consolas"/>
+              </a:rPr>
+              <a:t>@Override</a:t>
+            </a:r>
+            <a:r>
+              <a:rPr sz="1600" b="0">
+                <a:solidFill>
+                  <a:srgbClr val="FFFFFF"/>
+                </a:solidFill>
+                <a:latin typeface="Century Gothic"/>
+              </a:rPr>
+              <a:t>: sobrescribir es cambiar un método del padre.</a:t>
+            </a:r>
+          </a:p>
+        </p:txBody>
+      </p:sp>
+      <p:sp>
+        <p:nvSpPr>
+          <p:cNvPr id="8" name="TextBox 7"/>
+          <p:cNvSpPr txBox="1"/>
+          <p:nvPr/>
+        </p:nvSpPr>
+        <p:spPr>
+          <a:xfrm>
+            <a:off x="548640" y="6400800"/>
+            <a:ext cx="8229600" cy="274320"/>
           </a:xfrm>
           <a:prstGeom prst="rect">
             <a:avLst/>
@@ -9369,603 +10709,20 @@
           <a:p>
             <a:pPr algn="l"/>
             <a:r>
-              <a:rPr sz="1400" b="0">
-                <a:solidFill>
-                  <a:srgbClr val="36B5FF"/>
-                </a:solidFill>
-                <a:latin typeface="Consolas"/>
-              </a:rPr>
-              <a:t>cd</a:t>
-            </a:r>
-            <a:r>
-              <a:rPr sz="1400" b="0">
+              <a:rPr sz="1200" b="0">
                 <a:solidFill>
                   <a:srgbClr val="C9D6E3"/>
                 </a:solidFill>
                 <a:latin typeface="Century Gothic"/>
               </a:rPr>
-              <a:t> a la carpeta del proyecto</a:t>
-            </a:r>
-          </a:p>
-        </p:txBody>
-      </p:sp>
-      <p:cxnSp>
-        <p:nvCxnSpPr>
-          <p:cNvPr id="7" name="Connector 6"/>
-          <p:cNvCxnSpPr/>
-          <p:nvPr/>
-        </p:nvCxnSpPr>
-        <p:spPr>
-          <a:xfrm>
-            <a:off x="3059353" y="3383280"/>
-            <a:ext cx="320040" cy="0"/>
-          </a:xfrm>
-          <a:prstGeom prst="line">
-            <a:avLst/>
-          </a:prstGeom>
-          <a:ln w="31750">
-            <a:solidFill>
-              <a:srgbClr val="36B5FF"/>
-            </a:solidFill>
-            <a:tailEnd type="triangle"/>
-          </a:ln>
-        </p:spPr>
-        <p:style>
-          <a:lnRef idx="2">
-            <a:schemeClr val="accent1"/>
-          </a:lnRef>
-          <a:fillRef idx="0">
-            <a:schemeClr val="accent1"/>
-          </a:fillRef>
-          <a:effectRef idx="1">
-            <a:schemeClr val="accent1"/>
-          </a:effectRef>
-          <a:fontRef idx="minor">
-            <a:schemeClr val="tx1"/>
-          </a:fontRef>
-        </p:style>
-      </p:cxnSp>
-      <p:sp>
-        <p:nvSpPr>
-          <p:cNvPr id="8" name="Rounded Rectangle 7"/>
-          <p:cNvSpPr/>
-          <p:nvPr/>
-        </p:nvSpPr>
-        <p:spPr>
-          <a:xfrm>
-            <a:off x="3425113" y="2057400"/>
-            <a:ext cx="2464993" cy="2651760"/>
-          </a:xfrm>
-          <a:prstGeom prst="roundRect">
-            <a:avLst>
-              <a:gd name="adj" fmla="val 6000"/>
-            </a:avLst>
-          </a:prstGeom>
-          <a:solidFill>
-            <a:srgbClr val="08264F"/>
-          </a:solidFill>
-          <a:ln w="15875">
-            <a:solidFill>
-              <a:srgbClr val="5EA7D8"/>
-            </a:solidFill>
-          </a:ln>
-        </p:spPr>
-        <p:style>
-          <a:lnRef idx="1">
-            <a:schemeClr val="accent1"/>
-          </a:lnRef>
-          <a:fillRef idx="3">
-            <a:schemeClr val="accent1"/>
-          </a:fillRef>
-          <a:effectRef idx="2">
-            <a:schemeClr val="accent1"/>
-          </a:effectRef>
-          <a:fontRef idx="minor">
-            <a:schemeClr val="lt1"/>
-          </a:fontRef>
-        </p:style>
-        <p:txBody>
-          <a:bodyPr rtlCol="0" anchor="ctr"/>
-          <a:lstStyle/>
-          <a:p>
-            <a:endParaRPr/>
+              <a:t>Semillero QA 2026 · Automatización Web · Clase 1 · 01-fundamentos-java-poo</a:t>
+            </a:r>
           </a:p>
         </p:txBody>
       </p:sp>
       <p:sp>
         <p:nvSpPr>
           <p:cNvPr id="9" name="TextBox 8"/>
-          <p:cNvSpPr txBox="1"/>
-          <p:nvPr/>
-        </p:nvSpPr>
-        <p:spPr>
-          <a:xfrm>
-            <a:off x="3653713" y="2286000"/>
-            <a:ext cx="2007793" cy="548640"/>
-          </a:xfrm>
-          <a:prstGeom prst="rect">
-            <a:avLst/>
-          </a:prstGeom>
-          <a:noFill/>
-        </p:spPr>
-        <p:txBody>
-          <a:bodyPr wrap="square" lIns="0" rIns="0" anchor="t">
-            <a:spAutoFit/>
-          </a:bodyPr>
-          <a:lstStyle/>
-          <a:p>
-            <a:pPr algn="l"/>
-            <a:r>
-              <a:rPr sz="1800" b="1">
-                <a:solidFill>
-                  <a:srgbClr val="FFFFFF"/>
-                </a:solidFill>
-                <a:latin typeface="Century Gothic"/>
-              </a:rPr>
-              <a:t>2. gradle run</a:t>
-            </a:r>
-          </a:p>
-        </p:txBody>
-      </p:sp>
-      <p:sp>
-        <p:nvSpPr>
-          <p:cNvPr id="10" name="TextBox 9"/>
-          <p:cNvSpPr txBox="1"/>
-          <p:nvPr/>
-        </p:nvSpPr>
-        <p:spPr>
-          <a:xfrm>
-            <a:off x="3653713" y="2788920"/>
-            <a:ext cx="2007793" cy="1737360"/>
-          </a:xfrm>
-          <a:prstGeom prst="rect">
-            <a:avLst/>
-          </a:prstGeom>
-          <a:noFill/>
-        </p:spPr>
-        <p:txBody>
-          <a:bodyPr wrap="square" lIns="0" rIns="0" anchor="t">
-            <a:spAutoFit/>
-          </a:bodyPr>
-          <a:lstStyle/>
-          <a:p>
-            <a:pPr algn="l"/>
-            <a:r>
-              <a:rPr sz="1400" b="0">
-                <a:solidFill>
-                  <a:srgbClr val="C9D6E3"/>
-                </a:solidFill>
-                <a:latin typeface="Century Gothic"/>
-              </a:rPr>
-              <a:t>Compila y ejecuta los ejemplos</a:t>
-            </a:r>
-          </a:p>
-        </p:txBody>
-      </p:sp>
-      <p:cxnSp>
-        <p:nvCxnSpPr>
-          <p:cNvPr id="11" name="Connector 10"/>
-          <p:cNvCxnSpPr/>
-          <p:nvPr/>
-        </p:nvCxnSpPr>
-        <p:spPr>
-          <a:xfrm>
-            <a:off x="5935826" y="3383280"/>
-            <a:ext cx="320040" cy="0"/>
-          </a:xfrm>
-          <a:prstGeom prst="line">
-            <a:avLst/>
-          </a:prstGeom>
-          <a:ln w="31750">
-            <a:solidFill>
-              <a:srgbClr val="36B5FF"/>
-            </a:solidFill>
-            <a:tailEnd type="triangle"/>
-          </a:ln>
-        </p:spPr>
-        <p:style>
-          <a:lnRef idx="2">
-            <a:schemeClr val="accent1"/>
-          </a:lnRef>
-          <a:fillRef idx="0">
-            <a:schemeClr val="accent1"/>
-          </a:fillRef>
-          <a:effectRef idx="1">
-            <a:schemeClr val="accent1"/>
-          </a:effectRef>
-          <a:fontRef idx="minor">
-            <a:schemeClr val="tx1"/>
-          </a:fontRef>
-        </p:style>
-      </p:cxnSp>
-      <p:sp>
-        <p:nvSpPr>
-          <p:cNvPr id="12" name="Rounded Rectangle 11"/>
-          <p:cNvSpPr/>
-          <p:nvPr/>
-        </p:nvSpPr>
-        <p:spPr>
-          <a:xfrm>
-            <a:off x="6301586" y="2057400"/>
-            <a:ext cx="2464993" cy="2651760"/>
-          </a:xfrm>
-          <a:prstGeom prst="roundRect">
-            <a:avLst>
-              <a:gd name="adj" fmla="val 6000"/>
-            </a:avLst>
-          </a:prstGeom>
-          <a:solidFill>
-            <a:srgbClr val="0B2C59"/>
-          </a:solidFill>
-          <a:ln w="15875">
-            <a:solidFill>
-              <a:srgbClr val="5EA7D8"/>
-            </a:solidFill>
-          </a:ln>
-        </p:spPr>
-        <p:style>
-          <a:lnRef idx="1">
-            <a:schemeClr val="accent1"/>
-          </a:lnRef>
-          <a:fillRef idx="3">
-            <a:schemeClr val="accent1"/>
-          </a:fillRef>
-          <a:effectRef idx="2">
-            <a:schemeClr val="accent1"/>
-          </a:effectRef>
-          <a:fontRef idx="minor">
-            <a:schemeClr val="lt1"/>
-          </a:fontRef>
-        </p:style>
-        <p:txBody>
-          <a:bodyPr rtlCol="0" anchor="ctr"/>
-          <a:lstStyle/>
-          <a:p>
-            <a:endParaRPr/>
-          </a:p>
-        </p:txBody>
-      </p:sp>
-      <p:sp>
-        <p:nvSpPr>
-          <p:cNvPr id="13" name="TextBox 12"/>
-          <p:cNvSpPr txBox="1"/>
-          <p:nvPr/>
-        </p:nvSpPr>
-        <p:spPr>
-          <a:xfrm>
-            <a:off x="6530186" y="2286000"/>
-            <a:ext cx="2007793" cy="548640"/>
-          </a:xfrm>
-          <a:prstGeom prst="rect">
-            <a:avLst/>
-          </a:prstGeom>
-          <a:noFill/>
-        </p:spPr>
-        <p:txBody>
-          <a:bodyPr wrap="square" lIns="0" rIns="0" anchor="t">
-            <a:spAutoFit/>
-          </a:bodyPr>
-          <a:lstStyle/>
-          <a:p>
-            <a:pPr algn="l"/>
-            <a:r>
-              <a:rPr sz="1800" b="1">
-                <a:solidFill>
-                  <a:srgbClr val="FFFFFF"/>
-                </a:solidFill>
-                <a:latin typeface="Century Gothic"/>
-              </a:rPr>
-              <a:t>3. Lee la consola</a:t>
-            </a:r>
-          </a:p>
-        </p:txBody>
-      </p:sp>
-      <p:sp>
-        <p:nvSpPr>
-          <p:cNvPr id="14" name="TextBox 13"/>
-          <p:cNvSpPr txBox="1"/>
-          <p:nvPr/>
-        </p:nvSpPr>
-        <p:spPr>
-          <a:xfrm>
-            <a:off x="6530186" y="2788920"/>
-            <a:ext cx="2007793" cy="1737360"/>
-          </a:xfrm>
-          <a:prstGeom prst="rect">
-            <a:avLst/>
-          </a:prstGeom>
-          <a:noFill/>
-        </p:spPr>
-        <p:txBody>
-          <a:bodyPr wrap="square" lIns="0" rIns="0" anchor="t">
-            <a:spAutoFit/>
-          </a:bodyPr>
-          <a:lstStyle/>
-          <a:p>
-            <a:pPr algn="l"/>
-            <a:r>
-              <a:rPr sz="1400" b="0">
-                <a:solidFill>
-                  <a:srgbClr val="C9D6E3"/>
-                </a:solidFill>
-                <a:latin typeface="Century Gothic"/>
-              </a:rPr>
-              <a:t>Un título por tema y </a:t>
-            </a:r>
-            <a:r>
-              <a:rPr sz="1400" b="0">
-                <a:solidFill>
-                  <a:srgbClr val="36B5FF"/>
-                </a:solidFill>
-                <a:latin typeface="Consolas"/>
-              </a:rPr>
-              <a:t>BUILD SUCCESSFUL</a:t>
-            </a:r>
-            <a:r>
-              <a:rPr sz="1400" b="0">
-                <a:solidFill>
-                  <a:srgbClr val="C9D6E3"/>
-                </a:solidFill>
-                <a:latin typeface="Century Gothic"/>
-              </a:rPr>
-              <a:t> al final</a:t>
-            </a:r>
-          </a:p>
-        </p:txBody>
-      </p:sp>
-      <p:cxnSp>
-        <p:nvCxnSpPr>
-          <p:cNvPr id="15" name="Connector 14"/>
-          <p:cNvCxnSpPr/>
-          <p:nvPr/>
-        </p:nvCxnSpPr>
-        <p:spPr>
-          <a:xfrm>
-            <a:off x="8812299" y="3383280"/>
-            <a:ext cx="320040" cy="0"/>
-          </a:xfrm>
-          <a:prstGeom prst="line">
-            <a:avLst/>
-          </a:prstGeom>
-          <a:ln w="31750">
-            <a:solidFill>
-              <a:srgbClr val="36B5FF"/>
-            </a:solidFill>
-            <a:tailEnd type="triangle"/>
-          </a:ln>
-        </p:spPr>
-        <p:style>
-          <a:lnRef idx="2">
-            <a:schemeClr val="accent1"/>
-          </a:lnRef>
-          <a:fillRef idx="0">
-            <a:schemeClr val="accent1"/>
-          </a:fillRef>
-          <a:effectRef idx="1">
-            <a:schemeClr val="accent1"/>
-          </a:effectRef>
-          <a:fontRef idx="minor">
-            <a:schemeClr val="tx1"/>
-          </a:fontRef>
-        </p:style>
-      </p:cxnSp>
-      <p:sp>
-        <p:nvSpPr>
-          <p:cNvPr id="16" name="Rounded Rectangle 15"/>
-          <p:cNvSpPr/>
-          <p:nvPr/>
-        </p:nvSpPr>
-        <p:spPr>
-          <a:xfrm>
-            <a:off x="9178059" y="2057400"/>
-            <a:ext cx="2464993" cy="2651760"/>
-          </a:xfrm>
-          <a:prstGeom prst="roundRect">
-            <a:avLst>
-              <a:gd name="adj" fmla="val 6000"/>
-            </a:avLst>
-          </a:prstGeom>
-          <a:solidFill>
-            <a:srgbClr val="08264F"/>
-          </a:solidFill>
-          <a:ln w="15875">
-            <a:solidFill>
-              <a:srgbClr val="5EA7D8"/>
-            </a:solidFill>
-          </a:ln>
-        </p:spPr>
-        <p:style>
-          <a:lnRef idx="1">
-            <a:schemeClr val="accent1"/>
-          </a:lnRef>
-          <a:fillRef idx="3">
-            <a:schemeClr val="accent1"/>
-          </a:fillRef>
-          <a:effectRef idx="2">
-            <a:schemeClr val="accent1"/>
-          </a:effectRef>
-          <a:fontRef idx="minor">
-            <a:schemeClr val="lt1"/>
-          </a:fontRef>
-        </p:style>
-        <p:txBody>
-          <a:bodyPr rtlCol="0" anchor="ctr"/>
-          <a:lstStyle/>
-          <a:p>
-            <a:endParaRPr/>
-          </a:p>
-        </p:txBody>
-      </p:sp>
-      <p:sp>
-        <p:nvSpPr>
-          <p:cNvPr id="17" name="TextBox 16"/>
-          <p:cNvSpPr txBox="1"/>
-          <p:nvPr/>
-        </p:nvSpPr>
-        <p:spPr>
-          <a:xfrm>
-            <a:off x="9406659" y="2286000"/>
-            <a:ext cx="2007793" cy="548640"/>
-          </a:xfrm>
-          <a:prstGeom prst="rect">
-            <a:avLst/>
-          </a:prstGeom>
-          <a:noFill/>
-        </p:spPr>
-        <p:txBody>
-          <a:bodyPr wrap="square" lIns="0" rIns="0" anchor="t">
-            <a:spAutoFit/>
-          </a:bodyPr>
-          <a:lstStyle/>
-          <a:p>
-            <a:pPr algn="l"/>
-            <a:r>
-              <a:rPr sz="1800" b="1">
-                <a:solidFill>
-                  <a:srgbClr val="FFFFFF"/>
-                </a:solidFill>
-                <a:latin typeface="Century Gothic"/>
-              </a:rPr>
-              <a:t>4. Si falla</a:t>
-            </a:r>
-          </a:p>
-        </p:txBody>
-      </p:sp>
-      <p:sp>
-        <p:nvSpPr>
-          <p:cNvPr id="18" name="TextBox 17"/>
-          <p:cNvSpPr txBox="1"/>
-          <p:nvPr/>
-        </p:nvSpPr>
-        <p:spPr>
-          <a:xfrm>
-            <a:off x="9406659" y="2788920"/>
-            <a:ext cx="2007793" cy="1737360"/>
-          </a:xfrm>
-          <a:prstGeom prst="rect">
-            <a:avLst/>
-          </a:prstGeom>
-          <a:noFill/>
-        </p:spPr>
-        <p:txBody>
-          <a:bodyPr wrap="square" lIns="0" rIns="0" anchor="t">
-            <a:spAutoFit/>
-          </a:bodyPr>
-          <a:lstStyle/>
-          <a:p>
-            <a:pPr algn="l"/>
-            <a:r>
-              <a:rPr sz="1400" b="0">
-                <a:solidFill>
-                  <a:srgbClr val="C9D6E3"/>
-                </a:solidFill>
-                <a:latin typeface="Century Gothic"/>
-              </a:rPr>
-              <a:t>Busca archivo, línea y mensaje: </a:t>
-            </a:r>
-            <a:r>
-              <a:rPr sz="1400" b="0">
-                <a:solidFill>
-                  <a:srgbClr val="36B5FF"/>
-                </a:solidFill>
-                <a:latin typeface="Consolas"/>
-              </a:rPr>
-              <a:t>Variables.java:9: error: ';' expected</a:t>
-            </a:r>
-          </a:p>
-        </p:txBody>
-      </p:sp>
-      <p:sp>
-        <p:nvSpPr>
-          <p:cNvPr id="19" name="TextBox 18"/>
-          <p:cNvSpPr txBox="1"/>
-          <p:nvPr/>
-        </p:nvSpPr>
-        <p:spPr>
-          <a:xfrm>
-            <a:off x="548640" y="5029200"/>
-            <a:ext cx="11094415" cy="1097280"/>
-          </a:xfrm>
-          <a:prstGeom prst="rect">
-            <a:avLst/>
-          </a:prstGeom>
-          <a:noFill/>
-        </p:spPr>
-        <p:txBody>
-          <a:bodyPr wrap="square" lIns="0" rIns="0" anchor="t">
-            <a:spAutoFit/>
-          </a:bodyPr>
-          <a:lstStyle/>
-          <a:p>
-            <a:pPr algn="l"/>
-            <a:r>
-              <a:rPr sz="1600" b="0">
-                <a:solidFill>
-                  <a:srgbClr val="C9D6E3"/>
-                </a:solidFill>
-                <a:latin typeface="Century Gothic"/>
-              </a:rPr>
-              <a:t>Otro error que vas a ver: </a:t>
-            </a:r>
-            <a:r>
-              <a:rPr sz="1600" b="0">
-                <a:solidFill>
-                  <a:srgbClr val="36B5FF"/>
-                </a:solidFill>
-                <a:latin typeface="Consolas"/>
-              </a:rPr>
-              <a:t>saldo has private access in CuentaBancaria</a:t>
-            </a:r>
-            <a:r>
-              <a:rPr sz="1600" b="0">
-                <a:solidFill>
-                  <a:srgbClr val="C9D6E3"/>
-                </a:solidFill>
-                <a:latin typeface="Century Gothic"/>
-              </a:rPr>
-              <a:t>. Es el encapsulamiento protegiendo el dato.</a:t>
-            </a:r>
-          </a:p>
-        </p:txBody>
-      </p:sp>
-      <p:sp>
-        <p:nvSpPr>
-          <p:cNvPr id="20" name="TextBox 19"/>
-          <p:cNvSpPr txBox="1"/>
-          <p:nvPr/>
-        </p:nvSpPr>
-        <p:spPr>
-          <a:xfrm>
-            <a:off x="548640" y="6400800"/>
-            <a:ext cx="8229600" cy="274320"/>
-          </a:xfrm>
-          <a:prstGeom prst="rect">
-            <a:avLst/>
-          </a:prstGeom>
-          <a:noFill/>
-        </p:spPr>
-        <p:txBody>
-          <a:bodyPr wrap="square" lIns="0" rIns="0" anchor="t">
-            <a:spAutoFit/>
-          </a:bodyPr>
-          <a:lstStyle/>
-          <a:p>
-            <a:pPr algn="l"/>
-            <a:r>
-              <a:rPr sz="1200" b="0">
-                <a:solidFill>
-                  <a:srgbClr val="C9D6E3"/>
-                </a:solidFill>
-                <a:latin typeface="Century Gothic"/>
-              </a:rPr>
-              <a:t>Semillero QA 2026 · Automatización Web · Clase 1 · 01-fundamentos-java-poo</a:t>
-            </a:r>
-          </a:p>
-        </p:txBody>
-      </p:sp>
-      <p:sp>
-        <p:nvSpPr>
-          <p:cNvPr id="21" name="TextBox 20"/>
           <p:cNvSpPr txBox="1"/>
           <p:nvPr/>
         </p:nvSpPr>

</xml_diff>